<commit_message>
fix: refine technical PowerPoint architecture visuals
</commit_message>
<xml_diff>
--- a/docs/presentations/AI-ChotBot-technical-achievements.pptx
+++ b/docs/presentations/AI-ChotBot-technical-achievements.pptx
@@ -4739,7 +4739,7 @@
           <a:p>
             <a:pPr algn="l"/>
             <a:r>
-              <a:rPr sz="1550" b="1">
+              <a:rPr sz="1600" b="1">
                 <a:solidFill>
                   <a:srgbClr val="F4F8FC"/>
                 </a:solidFill>
@@ -4865,7 +4865,7 @@
           <a:p>
             <a:pPr algn="l"/>
             <a:r>
-              <a:rPr sz="1550" b="0">
+              <a:rPr sz="1600" b="0">
                 <a:solidFill>
                   <a:srgbClr val="F4F8FC"/>
                 </a:solidFill>
@@ -4921,7 +4921,7 @@
           <a:p>
             <a:pPr algn="l"/>
             <a:r>
-              <a:rPr sz="1550" b="0">
+              <a:rPr sz="1600" b="0">
                 <a:solidFill>
                   <a:srgbClr val="F4F8FC"/>
                 </a:solidFill>
@@ -4977,7 +4977,7 @@
           <a:p>
             <a:pPr algn="l"/>
             <a:r>
-              <a:rPr sz="1550" b="0">
+              <a:rPr sz="1600" b="0">
                 <a:solidFill>
                   <a:srgbClr val="F4F8FC"/>
                 </a:solidFill>
@@ -5033,7 +5033,7 @@
           <a:p>
             <a:pPr algn="l"/>
             <a:r>
-              <a:rPr sz="1550" b="0">
+              <a:rPr sz="1600" b="0">
                 <a:solidFill>
                   <a:srgbClr val="F4F8FC"/>
                 </a:solidFill>
@@ -5228,7 +5228,7 @@
           <a:p>
             <a:pPr algn="l"/>
             <a:r>
-              <a:rPr sz="1550" b="1">
+              <a:rPr sz="1600" b="1">
                 <a:solidFill>
                   <a:srgbClr val="F4F8FC"/>
                 </a:solidFill>
@@ -5317,8 +5317,8 @@
         </p:nvSpPr>
         <p:spPr>
           <a:xfrm>
-            <a:off x="640080" y="1874519"/>
-            <a:ext cx="5321808" cy="2007107"/>
+            <a:off x="640080" y="5074920"/>
+            <a:ext cx="3493008" cy="512064"/>
           </a:xfrm>
           <a:prstGeom prst="roundRect">
             <a:avLst>
@@ -5354,7 +5354,7 @@
           <a:p>
             <a:pPr algn="l"/>
             <a:r>
-              <a:rPr sz="1550" b="0">
+              <a:rPr sz="1600" b="0">
                 <a:solidFill>
                   <a:srgbClr val="F4F8FC"/>
                 </a:solidFill>
@@ -5373,8 +5373,8 @@
         </p:nvSpPr>
         <p:spPr>
           <a:xfrm>
-            <a:off x="6236208" y="1874519"/>
-            <a:ext cx="5321808" cy="2007107"/>
+            <a:off x="4315968" y="5074920"/>
+            <a:ext cx="3493008" cy="512064"/>
           </a:xfrm>
           <a:prstGeom prst="roundRect">
             <a:avLst>
@@ -5410,7 +5410,7 @@
           <a:p>
             <a:pPr algn="l"/>
             <a:r>
-              <a:rPr sz="1550" b="0">
+              <a:rPr sz="1600" b="0">
                 <a:solidFill>
                   <a:srgbClr val="F4F8FC"/>
                 </a:solidFill>
@@ -5429,8 +5429,8 @@
         </p:nvSpPr>
         <p:spPr>
           <a:xfrm>
-            <a:off x="640080" y="4027931"/>
-            <a:ext cx="5321808" cy="2007107"/>
+            <a:off x="7991855" y="5074920"/>
+            <a:ext cx="3493008" cy="512064"/>
           </a:xfrm>
           <a:prstGeom prst="roundRect">
             <a:avLst>
@@ -5466,7 +5466,7 @@
           <a:p>
             <a:pPr algn="l"/>
             <a:r>
-              <a:rPr sz="1550" b="0">
+              <a:rPr sz="1600" b="0">
                 <a:solidFill>
                   <a:srgbClr val="F4F8FC"/>
                 </a:solidFill>
@@ -5485,8 +5485,8 @@
         </p:nvSpPr>
         <p:spPr>
           <a:xfrm>
-            <a:off x="6236208" y="4027931"/>
-            <a:ext cx="5321808" cy="2007107"/>
+            <a:off x="640080" y="5696712"/>
+            <a:ext cx="3493008" cy="512064"/>
           </a:xfrm>
           <a:prstGeom prst="roundRect">
             <a:avLst>
@@ -5522,13 +5522,181 @@
           <a:p>
             <a:pPr algn="l"/>
             <a:r>
-              <a:rPr sz="1550" b="0">
+              <a:rPr sz="1600" b="0">
                 <a:solidFill>
                   <a:srgbClr val="F4F8FC"/>
                 </a:solidFill>
                 <a:latin typeface="Microsoft JhengHei"/>
               </a:rPr>
               <a:t>Traces 在第一階段維持停用，避免外部 URL 帶入使用者衍生資訊</a:t>
+            </a:r>
+          </a:p>
+        </p:txBody>
+      </p:sp>
+      <p:sp>
+        <p:nvSpPr>
+          <p:cNvPr id="12" name="privacy-layer-logs"/>
+          <p:cNvSpPr/>
+          <p:nvPr/>
+        </p:nvSpPr>
+        <p:spPr>
+          <a:xfrm>
+            <a:off x="822960" y="2148840"/>
+            <a:ext cx="2788920" cy="621792"/>
+          </a:xfrm>
+          <a:prstGeom prst="roundRect">
+            <a:avLst>
+              <a:gd name="adj" fmla="val 10000"/>
+            </a:avLst>
+          </a:prstGeom>
+          <a:solidFill>
+            <a:srgbClr val="102B46"/>
+          </a:solidFill>
+          <a:ln w="13970">
+            <a:solidFill>
+              <a:srgbClr val="21D4B4"/>
+            </a:solidFill>
+          </a:ln>
+        </p:spPr>
+        <p:style>
+          <a:lnRef idx="1">
+            <a:schemeClr val="accent1"/>
+          </a:lnRef>
+          <a:fillRef idx="3">
+            <a:schemeClr val="accent1"/>
+          </a:fillRef>
+          <a:effectRef idx="2">
+            <a:schemeClr val="accent1"/>
+          </a:effectRef>
+          <a:fontRef idx="minor">
+            <a:schemeClr val="lt1"/>
+          </a:fontRef>
+        </p:style>
+        <p:txBody>
+          <a:bodyPr rtlCol="0" anchor="ctr" wrap="square" lIns="109728" rIns="109728" tIns="64008" bIns="64008"/>
+          <a:lstStyle/>
+          <a:p>
+            <a:pPr algn="ctr"/>
+            <a:r>
+              <a:rPr sz="1400" b="1">
+                <a:solidFill>
+                  <a:srgbClr val="F4F8FC"/>
+                </a:solidFill>
+                <a:latin typeface="Microsoft JhengHei"/>
+              </a:rPr>
+              <a:t>Workers Logs</a:t>
+            </a:r>
+          </a:p>
+        </p:txBody>
+      </p:sp>
+      <p:sp>
+        <p:nvSpPr>
+          <p:cNvPr id="13" name="privacy-layer-d1"/>
+          <p:cNvSpPr/>
+          <p:nvPr/>
+        </p:nvSpPr>
+        <p:spPr>
+          <a:xfrm>
+            <a:off x="4572000" y="2148840"/>
+            <a:ext cx="2788920" cy="621792"/>
+          </a:xfrm>
+          <a:prstGeom prst="roundRect">
+            <a:avLst>
+              <a:gd name="adj" fmla="val 10000"/>
+            </a:avLst>
+          </a:prstGeom>
+          <a:solidFill>
+            <a:srgbClr val="102B46"/>
+          </a:solidFill>
+          <a:ln w="13970">
+            <a:solidFill>
+              <a:srgbClr val="4BA3FF"/>
+            </a:solidFill>
+          </a:ln>
+        </p:spPr>
+        <p:style>
+          <a:lnRef idx="1">
+            <a:schemeClr val="accent1"/>
+          </a:lnRef>
+          <a:fillRef idx="3">
+            <a:schemeClr val="accent1"/>
+          </a:fillRef>
+          <a:effectRef idx="2">
+            <a:schemeClr val="accent1"/>
+          </a:effectRef>
+          <a:fontRef idx="minor">
+            <a:schemeClr val="lt1"/>
+          </a:fontRef>
+        </p:style>
+        <p:txBody>
+          <a:bodyPr rtlCol="0" anchor="ctr" wrap="square" lIns="109728" rIns="109728" tIns="64008" bIns="64008"/>
+          <a:lstStyle/>
+          <a:p>
+            <a:pPr algn="ctr"/>
+            <a:r>
+              <a:rPr sz="1400" b="1">
+                <a:solidFill>
+                  <a:srgbClr val="F4F8FC"/>
+                </a:solidFill>
+                <a:latin typeface="Microsoft JhengHei"/>
+              </a:rPr>
+              <a:t>D1</a:t>
+            </a:r>
+          </a:p>
+        </p:txBody>
+      </p:sp>
+      <p:sp>
+        <p:nvSpPr>
+          <p:cNvPr id="14" name="privacy-layer-secrets"/>
+          <p:cNvSpPr/>
+          <p:nvPr/>
+        </p:nvSpPr>
+        <p:spPr>
+          <a:xfrm>
+            <a:off x="8321040" y="2148840"/>
+            <a:ext cx="2788920" cy="621792"/>
+          </a:xfrm>
+          <a:prstGeom prst="roundRect">
+            <a:avLst>
+              <a:gd name="adj" fmla="val 10000"/>
+            </a:avLst>
+          </a:prstGeom>
+          <a:solidFill>
+            <a:srgbClr val="102B46"/>
+          </a:solidFill>
+          <a:ln w="13970">
+            <a:solidFill>
+              <a:srgbClr val="FFBE55"/>
+            </a:solidFill>
+          </a:ln>
+        </p:spPr>
+        <p:style>
+          <a:lnRef idx="1">
+            <a:schemeClr val="accent1"/>
+          </a:lnRef>
+          <a:fillRef idx="3">
+            <a:schemeClr val="accent1"/>
+          </a:fillRef>
+          <a:effectRef idx="2">
+            <a:schemeClr val="accent1"/>
+          </a:effectRef>
+          <a:fontRef idx="minor">
+            <a:schemeClr val="lt1"/>
+          </a:fontRef>
+        </p:style>
+        <p:txBody>
+          <a:bodyPr rtlCol="0" anchor="ctr" wrap="square" lIns="109728" rIns="109728" tIns="64008" bIns="64008"/>
+          <a:lstStyle/>
+          <a:p>
+            <a:pPr algn="ctr"/>
+            <a:r>
+              <a:rPr sz="1400" b="1">
+                <a:solidFill>
+                  <a:srgbClr val="F4F8FC"/>
+                </a:solidFill>
+                <a:latin typeface="Microsoft JhengHei"/>
+              </a:rPr>
+              <a:t>Cloudflare secrets</a:t>
             </a:r>
           </a:p>
         </p:txBody>
@@ -5717,7 +5885,7 @@
           <a:p>
             <a:pPr algn="l"/>
             <a:r>
-              <a:rPr sz="1550" b="1">
+              <a:rPr sz="1600" b="1">
                 <a:solidFill>
                   <a:srgbClr val="F4F8FC"/>
                 </a:solidFill>
@@ -5807,7 +5975,7 @@
         <p:spPr>
           <a:xfrm>
             <a:off x="640080" y="5074920"/>
-            <a:ext cx="5321808" cy="475488"/>
+            <a:ext cx="3493008" cy="512064"/>
           </a:xfrm>
           <a:prstGeom prst="roundRect">
             <a:avLst>
@@ -5843,7 +6011,7 @@
           <a:p>
             <a:pPr algn="l"/>
             <a:r>
-              <a:rPr sz="1250" b="0">
+              <a:rPr sz="1600" b="0">
                 <a:solidFill>
                   <a:srgbClr val="F4F8FC"/>
                 </a:solidFill>
@@ -5862,8 +6030,8 @@
         </p:nvSpPr>
         <p:spPr>
           <a:xfrm>
-            <a:off x="6236208" y="5074920"/>
-            <a:ext cx="5321808" cy="475488"/>
+            <a:off x="4315968" y="5074920"/>
+            <a:ext cx="3493008" cy="512064"/>
           </a:xfrm>
           <a:prstGeom prst="roundRect">
             <a:avLst>
@@ -5899,7 +6067,7 @@
           <a:p>
             <a:pPr algn="l"/>
             <a:r>
-              <a:rPr sz="1250" b="0">
+              <a:rPr sz="1600" b="0">
                 <a:solidFill>
                   <a:srgbClr val="F4F8FC"/>
                 </a:solidFill>
@@ -5918,8 +6086,8 @@
         </p:nvSpPr>
         <p:spPr>
           <a:xfrm>
-            <a:off x="640080" y="5696712"/>
-            <a:ext cx="5321808" cy="475488"/>
+            <a:off x="7991855" y="5074920"/>
+            <a:ext cx="3493008" cy="512064"/>
           </a:xfrm>
           <a:prstGeom prst="roundRect">
             <a:avLst>
@@ -5955,7 +6123,7 @@
           <a:p>
             <a:pPr algn="l"/>
             <a:r>
-              <a:rPr sz="1250" b="0">
+              <a:rPr sz="1600" b="0">
                 <a:solidFill>
                   <a:srgbClr val="F4F8FC"/>
                 </a:solidFill>
@@ -5974,8 +6142,8 @@
         </p:nvSpPr>
         <p:spPr>
           <a:xfrm>
-            <a:off x="6236208" y="5696712"/>
-            <a:ext cx="5321808" cy="475488"/>
+            <a:off x="640080" y="5696712"/>
+            <a:ext cx="3493008" cy="512064"/>
           </a:xfrm>
           <a:prstGeom prst="roundRect">
             <a:avLst>
@@ -6011,7 +6179,7 @@
           <a:p>
             <a:pPr algn="l"/>
             <a:r>
-              <a:rPr sz="1250" b="0">
+              <a:rPr sz="1600" b="0">
                 <a:solidFill>
                   <a:srgbClr val="F4F8FC"/>
                 </a:solidFill>
@@ -6030,8 +6198,8 @@
         </p:nvSpPr>
         <p:spPr>
           <a:xfrm>
-            <a:off x="640080" y="6318504"/>
-            <a:ext cx="5321808" cy="475488"/>
+            <a:off x="4315968" y="5696712"/>
+            <a:ext cx="3493008" cy="512064"/>
           </a:xfrm>
           <a:prstGeom prst="roundRect">
             <a:avLst>
@@ -6067,7 +6235,7 @@
           <a:p>
             <a:pPr algn="l"/>
             <a:r>
-              <a:rPr sz="1250" b="0">
+              <a:rPr sz="1600" b="0">
                 <a:solidFill>
                   <a:srgbClr val="F4F8FC"/>
                 </a:solidFill>
@@ -6235,13 +6403,13 @@
           <a:p>
             <a:pPr algn="ctr"/>
             <a:r>
-              <a:rPr sz="1250" b="0">
+              <a:rPr sz="1200" b="0">
                 <a:solidFill>
                   <a:srgbClr val="F4F8FC"/>
                 </a:solidFill>
                 <a:latin typeface="Microsoft JhengHei"/>
               </a:rPr>
-              <a:t>可觀測事件 1</a:t>
+              <a:t>webhook.enqueue.completed</a:t>
             </a:r>
           </a:p>
         </p:txBody>
@@ -6291,13 +6459,13 @@
           <a:p>
             <a:pPr algn="ctr"/>
             <a:r>
-              <a:rPr sz="1250" b="0">
+              <a:rPr sz="1200" b="0">
                 <a:solidFill>
                   <a:srgbClr val="F4F8FC"/>
                 </a:solidFill>
                 <a:latin typeface="Microsoft JhengHei"/>
               </a:rPr>
-              <a:t>可觀測事件 2</a:t>
+              <a:t>question.started</a:t>
             </a:r>
           </a:p>
         </p:txBody>
@@ -6320,6 +6488,7 @@
             <a:solidFill>
               <a:srgbClr val="FFBE55"/>
             </a:solidFill>
+            <a:tailEnd type="triangle"/>
           </a:ln>
         </p:spPr>
         <p:style>
@@ -6382,13 +6551,13 @@
           <a:p>
             <a:pPr algn="ctr"/>
             <a:r>
-              <a:rPr sz="1250" b="0">
+              <a:rPr sz="1200" b="0">
                 <a:solidFill>
                   <a:srgbClr val="F4F8FC"/>
                 </a:solidFill>
                 <a:latin typeface="Microsoft JhengHei"/>
               </a:rPr>
-              <a:t>可觀測事件 3</a:t>
+              <a:t>storage.claim.completed</a:t>
             </a:r>
           </a:p>
         </p:txBody>
@@ -6411,6 +6580,7 @@
             <a:solidFill>
               <a:srgbClr val="FFBE55"/>
             </a:solidFill>
+            <a:tailEnd type="triangle"/>
           </a:ln>
         </p:spPr>
         <p:style>
@@ -6473,13 +6643,13 @@
           <a:p>
             <a:pPr algn="ctr"/>
             <a:r>
-              <a:rPr sz="1250" b="0">
+              <a:rPr sz="1200" b="0">
                 <a:solidFill>
                   <a:srgbClr val="F4F8FC"/>
                 </a:solidFill>
                 <a:latin typeface="Microsoft JhengHei"/>
               </a:rPr>
-              <a:t>可觀測事件 4</a:t>
+              <a:t>answer.completed</a:t>
             </a:r>
           </a:p>
         </p:txBody>
@@ -6502,6 +6672,7 @@
             <a:solidFill>
               <a:srgbClr val="FFBE55"/>
             </a:solidFill>
+            <a:tailEnd type="triangle"/>
           </a:ln>
         </p:spPr>
         <p:style>
@@ -6564,13 +6735,13 @@
           <a:p>
             <a:pPr algn="ctr"/>
             <a:r>
-              <a:rPr sz="1250" b="0">
+              <a:rPr sz="1200" b="0">
                 <a:solidFill>
                   <a:srgbClr val="F4F8FC"/>
                 </a:solidFill>
                 <a:latin typeface="Microsoft JhengHei"/>
               </a:rPr>
-              <a:t>可觀測事件 5</a:t>
+              <a:t>line.reply.completed</a:t>
             </a:r>
           </a:p>
         </p:txBody>
@@ -6593,6 +6764,7 @@
             <a:solidFill>
               <a:srgbClr val="FFBE55"/>
             </a:solidFill>
+            <a:tailEnd type="triangle"/>
           </a:ln>
         </p:spPr>
         <p:style>
@@ -6794,7 +6966,7 @@
           <a:p>
             <a:pPr algn="l"/>
             <a:r>
-              <a:rPr sz="1550" b="1">
+              <a:rPr sz="1600" b="1">
                 <a:solidFill>
                   <a:srgbClr val="F4F8FC"/>
                 </a:solidFill>
@@ -6884,7 +7056,7 @@
         <p:spPr>
           <a:xfrm>
             <a:off x="640080" y="5074920"/>
-            <a:ext cx="5321808" cy="475488"/>
+            <a:ext cx="3493008" cy="512064"/>
           </a:xfrm>
           <a:prstGeom prst="roundRect">
             <a:avLst>
@@ -6920,7 +7092,7 @@
           <a:p>
             <a:pPr algn="l"/>
             <a:r>
-              <a:rPr sz="1250" b="0">
+              <a:rPr sz="1600" b="0">
                 <a:solidFill>
                   <a:srgbClr val="F4F8FC"/>
                 </a:solidFill>
@@ -6939,8 +7111,8 @@
         </p:nvSpPr>
         <p:spPr>
           <a:xfrm>
-            <a:off x="6236208" y="5074920"/>
-            <a:ext cx="5321808" cy="475488"/>
+            <a:off x="4315968" y="5074920"/>
+            <a:ext cx="3493008" cy="512064"/>
           </a:xfrm>
           <a:prstGeom prst="roundRect">
             <a:avLst>
@@ -6976,7 +7148,7 @@
           <a:p>
             <a:pPr algn="l"/>
             <a:r>
-              <a:rPr sz="1250" b="0">
+              <a:rPr sz="1600" b="0">
                 <a:solidFill>
                   <a:srgbClr val="F4F8FC"/>
                 </a:solidFill>
@@ -6995,8 +7167,8 @@
         </p:nvSpPr>
         <p:spPr>
           <a:xfrm>
-            <a:off x="640080" y="5696712"/>
-            <a:ext cx="5321808" cy="475488"/>
+            <a:off x="7991855" y="5074920"/>
+            <a:ext cx="3493008" cy="512064"/>
           </a:xfrm>
           <a:prstGeom prst="roundRect">
             <a:avLst>
@@ -7032,7 +7204,7 @@
           <a:p>
             <a:pPr algn="l"/>
             <a:r>
-              <a:rPr sz="1250" b="0">
+              <a:rPr sz="1600" b="0">
                 <a:solidFill>
                   <a:srgbClr val="F4F8FC"/>
                 </a:solidFill>
@@ -7051,8 +7223,8 @@
         </p:nvSpPr>
         <p:spPr>
           <a:xfrm>
-            <a:off x="6236208" y="5696712"/>
-            <a:ext cx="5321808" cy="475488"/>
+            <a:off x="640080" y="5696712"/>
+            <a:ext cx="3493008" cy="512064"/>
           </a:xfrm>
           <a:prstGeom prst="roundRect">
             <a:avLst>
@@ -7088,7 +7260,7 @@
           <a:p>
             <a:pPr algn="l"/>
             <a:r>
-              <a:rPr sz="1250" b="0">
+              <a:rPr sz="1600" b="0">
                 <a:solidFill>
                   <a:srgbClr val="F4F8FC"/>
                 </a:solidFill>
@@ -7107,8 +7279,8 @@
         </p:nvSpPr>
         <p:spPr>
           <a:xfrm>
-            <a:off x="640080" y="6318504"/>
-            <a:ext cx="5321808" cy="475488"/>
+            <a:off x="4315968" y="5696712"/>
+            <a:ext cx="3493008" cy="512064"/>
           </a:xfrm>
           <a:prstGeom prst="roundRect">
             <a:avLst>
@@ -7144,7 +7316,7 @@
           <a:p>
             <a:pPr algn="l"/>
             <a:r>
-              <a:rPr sz="1250" b="0">
+              <a:rPr sz="1600" b="0">
                 <a:solidFill>
                   <a:srgbClr val="F4F8FC"/>
                 </a:solidFill>
@@ -7563,7 +7735,7 @@
           <a:p>
             <a:pPr algn="l"/>
             <a:r>
-              <a:rPr sz="1550" b="1">
+              <a:rPr sz="1600" b="1">
                 <a:solidFill>
                   <a:srgbClr val="F4F8FC"/>
                 </a:solidFill>
@@ -7653,7 +7825,7 @@
         <p:spPr>
           <a:xfrm>
             <a:off x="640080" y="5074920"/>
-            <a:ext cx="5321808" cy="475488"/>
+            <a:ext cx="3493008" cy="512064"/>
           </a:xfrm>
           <a:prstGeom prst="roundRect">
             <a:avLst>
@@ -7689,7 +7861,7 @@
           <a:p>
             <a:pPr algn="l"/>
             <a:r>
-              <a:rPr sz="1250" b="0">
+              <a:rPr sz="1600" b="0">
                 <a:solidFill>
                   <a:srgbClr val="F4F8FC"/>
                 </a:solidFill>
@@ -7708,8 +7880,8 @@
         </p:nvSpPr>
         <p:spPr>
           <a:xfrm>
-            <a:off x="6236208" y="5074920"/>
-            <a:ext cx="5321808" cy="475488"/>
+            <a:off x="4315968" y="5074920"/>
+            <a:ext cx="3493008" cy="512064"/>
           </a:xfrm>
           <a:prstGeom prst="roundRect">
             <a:avLst>
@@ -7745,7 +7917,7 @@
           <a:p>
             <a:pPr algn="l"/>
             <a:r>
-              <a:rPr sz="1250" b="0">
+              <a:rPr sz="1600" b="0">
                 <a:solidFill>
                   <a:srgbClr val="F4F8FC"/>
                 </a:solidFill>
@@ -7764,8 +7936,8 @@
         </p:nvSpPr>
         <p:spPr>
           <a:xfrm>
-            <a:off x="640080" y="5696712"/>
-            <a:ext cx="5321808" cy="475488"/>
+            <a:off x="7991855" y="5074920"/>
+            <a:ext cx="3493008" cy="512064"/>
           </a:xfrm>
           <a:prstGeom prst="roundRect">
             <a:avLst>
@@ -7801,7 +7973,7 @@
           <a:p>
             <a:pPr algn="l"/>
             <a:r>
-              <a:rPr sz="1250" b="0">
+              <a:rPr sz="1600" b="0">
                 <a:solidFill>
                   <a:srgbClr val="F4F8FC"/>
                 </a:solidFill>
@@ -7820,8 +7992,8 @@
         </p:nvSpPr>
         <p:spPr>
           <a:xfrm>
-            <a:off x="6236208" y="5696712"/>
-            <a:ext cx="5321808" cy="475488"/>
+            <a:off x="640080" y="5696712"/>
+            <a:ext cx="3493008" cy="512064"/>
           </a:xfrm>
           <a:prstGeom prst="roundRect">
             <a:avLst>
@@ -7857,7 +8029,7 @@
           <a:p>
             <a:pPr algn="l"/>
             <a:r>
-              <a:rPr sz="1250" b="0">
+              <a:rPr sz="1600" b="0">
                 <a:solidFill>
                   <a:srgbClr val="F4F8FC"/>
                 </a:solidFill>
@@ -7876,8 +8048,8 @@
         </p:nvSpPr>
         <p:spPr>
           <a:xfrm>
-            <a:off x="640080" y="6318504"/>
-            <a:ext cx="5321808" cy="475488"/>
+            <a:off x="4315968" y="5696712"/>
+            <a:ext cx="3493008" cy="512064"/>
           </a:xfrm>
           <a:prstGeom prst="roundRect">
             <a:avLst>
@@ -7913,7 +8085,7 @@
           <a:p>
             <a:pPr algn="l"/>
             <a:r>
-              <a:rPr sz="1250" b="0">
+              <a:rPr sz="1600" b="0">
                 <a:solidFill>
                   <a:srgbClr val="F4F8FC"/>
                 </a:solidFill>
@@ -8500,7 +8672,7 @@
           <a:p>
             <a:pPr algn="l"/>
             <a:r>
-              <a:rPr sz="1550" b="1">
+              <a:rPr sz="1600" b="1">
                 <a:solidFill>
                   <a:srgbClr val="F4F8FC"/>
                 </a:solidFill>
@@ -8590,7 +8762,7 @@
         <p:spPr>
           <a:xfrm>
             <a:off x="640080" y="5074920"/>
-            <a:ext cx="5321808" cy="475488"/>
+            <a:ext cx="3493008" cy="512064"/>
           </a:xfrm>
           <a:prstGeom prst="roundRect">
             <a:avLst>
@@ -8626,7 +8798,7 @@
           <a:p>
             <a:pPr algn="l"/>
             <a:r>
-              <a:rPr sz="1250" b="0">
+              <a:rPr sz="1600" b="0">
                 <a:solidFill>
                   <a:srgbClr val="F4F8FC"/>
                 </a:solidFill>
@@ -8645,8 +8817,8 @@
         </p:nvSpPr>
         <p:spPr>
           <a:xfrm>
-            <a:off x="6236208" y="5074920"/>
-            <a:ext cx="5321808" cy="475488"/>
+            <a:off x="4315968" y="5074920"/>
+            <a:ext cx="3493008" cy="512064"/>
           </a:xfrm>
           <a:prstGeom prst="roundRect">
             <a:avLst>
@@ -8682,7 +8854,7 @@
           <a:p>
             <a:pPr algn="l"/>
             <a:r>
-              <a:rPr sz="1250" b="0">
+              <a:rPr sz="1600" b="0">
                 <a:solidFill>
                   <a:srgbClr val="F4F8FC"/>
                 </a:solidFill>
@@ -8701,8 +8873,8 @@
         </p:nvSpPr>
         <p:spPr>
           <a:xfrm>
-            <a:off x="640080" y="5696712"/>
-            <a:ext cx="5321808" cy="475488"/>
+            <a:off x="7991855" y="5074920"/>
+            <a:ext cx="3493008" cy="512064"/>
           </a:xfrm>
           <a:prstGeom prst="roundRect">
             <a:avLst>
@@ -8738,7 +8910,7 @@
           <a:p>
             <a:pPr algn="l"/>
             <a:r>
-              <a:rPr sz="1250" b="0">
+              <a:rPr sz="1600" b="0">
                 <a:solidFill>
                   <a:srgbClr val="F4F8FC"/>
                 </a:solidFill>
@@ -8757,8 +8929,8 @@
         </p:nvSpPr>
         <p:spPr>
           <a:xfrm>
-            <a:off x="6236208" y="5696712"/>
-            <a:ext cx="5321808" cy="475488"/>
+            <a:off x="640080" y="5696712"/>
+            <a:ext cx="3493008" cy="512064"/>
           </a:xfrm>
           <a:prstGeom prst="roundRect">
             <a:avLst>
@@ -8794,7 +8966,7 @@
           <a:p>
             <a:pPr algn="l"/>
             <a:r>
-              <a:rPr sz="1250" b="0">
+              <a:rPr sz="1600" b="0">
                 <a:solidFill>
                   <a:srgbClr val="F4F8FC"/>
                 </a:solidFill>
@@ -9045,7 +9217,7 @@
           <a:p>
             <a:pPr algn="l"/>
             <a:r>
-              <a:rPr sz="1550" b="1">
+              <a:rPr sz="1600" b="1">
                 <a:solidFill>
                   <a:srgbClr val="F4F8FC"/>
                 </a:solidFill>
@@ -9171,7 +9343,7 @@
           <a:p>
             <a:pPr algn="l"/>
             <a:r>
-              <a:rPr sz="1550" b="0">
+              <a:rPr sz="1600" b="0">
                 <a:solidFill>
                   <a:srgbClr val="F4F8FC"/>
                 </a:solidFill>
@@ -9227,7 +9399,7 @@
           <a:p>
             <a:pPr algn="l"/>
             <a:r>
-              <a:rPr sz="1550" b="0">
+              <a:rPr sz="1600" b="0">
                 <a:solidFill>
                   <a:srgbClr val="F4F8FC"/>
                 </a:solidFill>
@@ -9283,7 +9455,7 @@
           <a:p>
             <a:pPr algn="l"/>
             <a:r>
-              <a:rPr sz="1550" b="0">
+              <a:rPr sz="1600" b="0">
                 <a:solidFill>
                   <a:srgbClr val="F4F8FC"/>
                 </a:solidFill>
@@ -9339,7 +9511,7 @@
           <a:p>
             <a:pPr algn="l"/>
             <a:r>
-              <a:rPr sz="1550" b="0">
+              <a:rPr sz="1600" b="0">
                 <a:solidFill>
                   <a:srgbClr val="F4F8FC"/>
                 </a:solidFill>
@@ -9534,7 +9706,7 @@
           <a:p>
             <a:pPr algn="l"/>
             <a:r>
-              <a:rPr sz="1550" b="1">
+              <a:rPr sz="1600" b="1">
                 <a:solidFill>
                   <a:srgbClr val="F4F8FC"/>
                 </a:solidFill>
@@ -9624,7 +9796,7 @@
         <p:spPr>
           <a:xfrm>
             <a:off x="640080" y="5074920"/>
-            <a:ext cx="5321808" cy="475488"/>
+            <a:ext cx="3493008" cy="512064"/>
           </a:xfrm>
           <a:prstGeom prst="roundRect">
             <a:avLst>
@@ -9660,7 +9832,7 @@
           <a:p>
             <a:pPr algn="l"/>
             <a:r>
-              <a:rPr sz="1250" b="0">
+              <a:rPr sz="1600" b="0">
                 <a:solidFill>
                   <a:srgbClr val="F4F8FC"/>
                 </a:solidFill>
@@ -9679,8 +9851,8 @@
         </p:nvSpPr>
         <p:spPr>
           <a:xfrm>
-            <a:off x="6236208" y="5074920"/>
-            <a:ext cx="5321808" cy="475488"/>
+            <a:off x="4315968" y="5074920"/>
+            <a:ext cx="3493008" cy="512064"/>
           </a:xfrm>
           <a:prstGeom prst="roundRect">
             <a:avLst>
@@ -9716,7 +9888,7 @@
           <a:p>
             <a:pPr algn="l"/>
             <a:r>
-              <a:rPr sz="1250" b="0">
+              <a:rPr sz="1600" b="0">
                 <a:solidFill>
                   <a:srgbClr val="F4F8FC"/>
                 </a:solidFill>
@@ -9735,8 +9907,8 @@
         </p:nvSpPr>
         <p:spPr>
           <a:xfrm>
-            <a:off x="640080" y="5696712"/>
-            <a:ext cx="5321808" cy="475488"/>
+            <a:off x="7991855" y="5074920"/>
+            <a:ext cx="3493008" cy="512064"/>
           </a:xfrm>
           <a:prstGeom prst="roundRect">
             <a:avLst>
@@ -9772,7 +9944,7 @@
           <a:p>
             <a:pPr algn="l"/>
             <a:r>
-              <a:rPr sz="1250" b="0">
+              <a:rPr sz="1600" b="0">
                 <a:solidFill>
                   <a:srgbClr val="F4F8FC"/>
                 </a:solidFill>
@@ -9791,8 +9963,8 @@
         </p:nvSpPr>
         <p:spPr>
           <a:xfrm>
-            <a:off x="6236208" y="5696712"/>
-            <a:ext cx="5321808" cy="475488"/>
+            <a:off x="640080" y="5696712"/>
+            <a:ext cx="3493008" cy="512064"/>
           </a:xfrm>
           <a:prstGeom prst="roundRect">
             <a:avLst>
@@ -9828,7 +10000,7 @@
           <a:p>
             <a:pPr algn="l"/>
             <a:r>
-              <a:rPr sz="1250" b="0">
+              <a:rPr sz="1600" b="0">
                 <a:solidFill>
                   <a:srgbClr val="F4F8FC"/>
                 </a:solidFill>
@@ -9847,8 +10019,8 @@
         </p:nvSpPr>
         <p:spPr>
           <a:xfrm>
-            <a:off x="640080" y="6318504"/>
-            <a:ext cx="5321808" cy="475488"/>
+            <a:off x="4315968" y="5696712"/>
+            <a:ext cx="3493008" cy="512064"/>
           </a:xfrm>
           <a:prstGeom prst="roundRect">
             <a:avLst>
@@ -9884,7 +10056,7 @@
           <a:p>
             <a:pPr algn="l"/>
             <a:r>
-              <a:rPr sz="1250" b="0">
+              <a:rPr sz="1600" b="0">
                 <a:solidFill>
                   <a:srgbClr val="F4F8FC"/>
                 </a:solidFill>
@@ -9940,13 +10112,13 @@
           <a:p>
             <a:pPr algn="ctr"/>
             <a:r>
-              <a:rPr sz="1250" b="1">
+              <a:rPr sz="1600" b="1">
                 <a:solidFill>
                   <a:srgbClr val="F4F8FC"/>
                 </a:solidFill>
                 <a:latin typeface="Microsoft JhengHei"/>
               </a:rPr>
-              <a:t>1. 完成分支：整理知識搜尋修改並完成審查</a:t>
+              <a:t>1. 完成分支</a:t>
             </a:r>
           </a:p>
         </p:txBody>
@@ -9996,13 +10168,13 @@
           <a:p>
             <a:pPr algn="ctr"/>
             <a:r>
-              <a:rPr sz="1250" b="1">
+              <a:rPr sz="1600" b="1">
                 <a:solidFill>
                   <a:srgbClr val="F4F8FC"/>
                 </a:solidFill>
                 <a:latin typeface="Microsoft JhengHei"/>
               </a:rPr>
-              <a:t>2. 自動化驗證：修正逾時並重跑品質閘門</a:t>
+              <a:t>2. 自動化驗證</a:t>
             </a:r>
           </a:p>
         </p:txBody>
@@ -10025,6 +10197,7 @@
             <a:solidFill>
               <a:srgbClr val="21D4B4"/>
             </a:solidFill>
+            <a:tailEnd type="triangle"/>
           </a:ln>
         </p:spPr>
         <p:style>
@@ -10087,13 +10260,13 @@
           <a:p>
             <a:pPr algn="ctr"/>
             <a:r>
-              <a:rPr sz="1250" b="1">
+              <a:rPr sz="1600" b="1">
                 <a:solidFill>
                   <a:srgbClr val="F4F8FC"/>
                 </a:solidFill>
                 <a:latin typeface="Microsoft JhengHei"/>
               </a:rPr>
-              <a:t>3. 合併：確認相容性與測試結果後納入主線</a:t>
+              <a:t>3. 合併</a:t>
             </a:r>
           </a:p>
         </p:txBody>
@@ -10116,6 +10289,7 @@
             <a:solidFill>
               <a:srgbClr val="21D4B4"/>
             </a:solidFill>
+            <a:tailEnd type="triangle"/>
           </a:ln>
         </p:spPr>
         <p:style>
@@ -10178,13 +10352,13 @@
           <a:p>
             <a:pPr algn="ctr"/>
             <a:r>
-              <a:rPr sz="1250" b="1">
+              <a:rPr sz="1600" b="1">
                 <a:solidFill>
                   <a:srgbClr val="F4F8FC"/>
                 </a:solidFill>
                 <a:latin typeface="Microsoft JhengHei"/>
               </a:rPr>
-              <a:t>4. 正式部署：依 migration 與部署程序建立可回復版本</a:t>
+              <a:t>4. 正式部署</a:t>
             </a:r>
           </a:p>
         </p:txBody>
@@ -10207,6 +10381,7 @@
             <a:solidFill>
               <a:srgbClr val="FFBE55"/>
             </a:solidFill>
+            <a:tailEnd type="triangle"/>
           </a:ln>
         </p:spPr>
         <p:style>
@@ -10269,13 +10444,13 @@
           <a:p>
             <a:pPr algn="ctr"/>
             <a:r>
-              <a:rPr sz="1250" b="1">
+              <a:rPr sz="1600" b="1">
                 <a:solidFill>
                   <a:srgbClr val="F4F8FC"/>
                 </a:solidFill>
                 <a:latin typeface="Microsoft JhengHei"/>
               </a:rPr>
-              <a:t>5. 實機驗收：完成 LINE、Logs、Queue、D1 與隱私檢查</a:t>
+              <a:t>5. 實機驗收</a:t>
             </a:r>
           </a:p>
         </p:txBody>
@@ -10298,6 +10473,7 @@
             <a:solidFill>
               <a:srgbClr val="FFBE55"/>
             </a:solidFill>
+            <a:tailEnd type="triangle"/>
           </a:ln>
         </p:spPr>
         <p:style>
@@ -10499,7 +10675,7 @@
           <a:p>
             <a:pPr algn="l"/>
             <a:r>
-              <a:rPr sz="1550" b="1">
+              <a:rPr sz="1600" b="1">
                 <a:solidFill>
                   <a:srgbClr val="F4F8FC"/>
                 </a:solidFill>
@@ -10625,7 +10801,7 @@
           <a:p>
             <a:pPr algn="l"/>
             <a:r>
-              <a:rPr sz="1550" b="0">
+              <a:rPr sz="1600" b="0">
                 <a:solidFill>
                   <a:srgbClr val="F4F8FC"/>
                 </a:solidFill>
@@ -10681,7 +10857,7 @@
           <a:p>
             <a:pPr algn="l"/>
             <a:r>
-              <a:rPr sz="1550" b="0">
+              <a:rPr sz="1600" b="0">
                 <a:solidFill>
                   <a:srgbClr val="F4F8FC"/>
                 </a:solidFill>
@@ -10737,7 +10913,7 @@
           <a:p>
             <a:pPr algn="l"/>
             <a:r>
-              <a:rPr sz="1550" b="0">
+              <a:rPr sz="1600" b="0">
                 <a:solidFill>
                   <a:srgbClr val="F4F8FC"/>
                 </a:solidFill>
@@ -10793,7 +10969,7 @@
           <a:p>
             <a:pPr algn="l"/>
             <a:r>
-              <a:rPr sz="1550" b="0">
+              <a:rPr sz="1600" b="0">
                 <a:solidFill>
                   <a:srgbClr val="F4F8FC"/>
                 </a:solidFill>
@@ -10988,7 +11164,7 @@
           <a:p>
             <a:pPr algn="l"/>
             <a:r>
-              <a:rPr sz="1550" b="1">
+              <a:rPr sz="1600" b="1">
                 <a:solidFill>
                   <a:srgbClr val="F4F8FC"/>
                 </a:solidFill>
@@ -11078,7 +11254,7 @@
         <p:spPr>
           <a:xfrm>
             <a:off x="640080" y="5074920"/>
-            <a:ext cx="5321808" cy="475488"/>
+            <a:ext cx="3493008" cy="512064"/>
           </a:xfrm>
           <a:prstGeom prst="roundRect">
             <a:avLst>
@@ -11114,7 +11290,7 @@
           <a:p>
             <a:pPr algn="l"/>
             <a:r>
-              <a:rPr sz="1250" b="0">
+              <a:rPr sz="1600" b="0">
                 <a:solidFill>
                   <a:srgbClr val="F4F8FC"/>
                 </a:solidFill>
@@ -11133,8 +11309,8 @@
         </p:nvSpPr>
         <p:spPr>
           <a:xfrm>
-            <a:off x="6236208" y="5074920"/>
-            <a:ext cx="5321808" cy="475488"/>
+            <a:off x="4315968" y="5074920"/>
+            <a:ext cx="3493008" cy="512064"/>
           </a:xfrm>
           <a:prstGeom prst="roundRect">
             <a:avLst>
@@ -11170,7 +11346,7 @@
           <a:p>
             <a:pPr algn="l"/>
             <a:r>
-              <a:rPr sz="1250" b="0">
+              <a:rPr sz="1600" b="0">
                 <a:solidFill>
                   <a:srgbClr val="F4F8FC"/>
                 </a:solidFill>
@@ -11189,8 +11365,8 @@
         </p:nvSpPr>
         <p:spPr>
           <a:xfrm>
-            <a:off x="640080" y="5696712"/>
-            <a:ext cx="5321808" cy="475488"/>
+            <a:off x="7991855" y="5074920"/>
+            <a:ext cx="3493008" cy="512064"/>
           </a:xfrm>
           <a:prstGeom prst="roundRect">
             <a:avLst>
@@ -11226,7 +11402,7 @@
           <a:p>
             <a:pPr algn="l"/>
             <a:r>
-              <a:rPr sz="1250" b="0">
+              <a:rPr sz="1600" b="0">
                 <a:solidFill>
                   <a:srgbClr val="F4F8FC"/>
                 </a:solidFill>
@@ -11245,8 +11421,8 @@
         </p:nvSpPr>
         <p:spPr>
           <a:xfrm>
-            <a:off x="6236208" y="5696712"/>
-            <a:ext cx="5321808" cy="475488"/>
+            <a:off x="640080" y="5696712"/>
+            <a:ext cx="3493008" cy="512064"/>
           </a:xfrm>
           <a:prstGeom prst="roundRect">
             <a:avLst>
@@ -11282,7 +11458,7 @@
           <a:p>
             <a:pPr algn="l"/>
             <a:r>
-              <a:rPr sz="1250" b="0">
+              <a:rPr sz="1600" b="0">
                 <a:solidFill>
                   <a:srgbClr val="F4F8FC"/>
                 </a:solidFill>
@@ -11710,6 +11886,7 @@
             <a:solidFill>
               <a:srgbClr val="21D4B4"/>
             </a:solidFill>
+            <a:tailEnd type="triangle"/>
           </a:ln>
         </p:spPr>
         <p:style>
@@ -11745,6 +11922,7 @@
             <a:solidFill>
               <a:srgbClr val="21D4B4"/>
             </a:solidFill>
+            <a:tailEnd type="triangle"/>
           </a:ln>
         </p:spPr>
         <p:style>
@@ -11780,6 +11958,7 @@
             <a:solidFill>
               <a:srgbClr val="21D4B4"/>
             </a:solidFill>
+            <a:tailEnd type="triangle"/>
           </a:ln>
         </p:spPr>
         <p:style>
@@ -11815,6 +11994,7 @@
             <a:solidFill>
               <a:srgbClr val="21D4B4"/>
             </a:solidFill>
+            <a:tailEnd type="triangle"/>
           </a:ln>
         </p:spPr>
         <p:style>
@@ -11850,6 +12030,7 @@
             <a:solidFill>
               <a:srgbClr val="21D4B4"/>
             </a:solidFill>
+            <a:tailEnd type="triangle"/>
           </a:ln>
         </p:spPr>
         <p:style>
@@ -11885,6 +12066,7 @@
             <a:solidFill>
               <a:srgbClr val="21D4B4"/>
             </a:solidFill>
+            <a:tailEnd type="triangle"/>
           </a:ln>
         </p:spPr>
         <p:style>
@@ -12086,7 +12268,7 @@
           <a:p>
             <a:pPr algn="l"/>
             <a:r>
-              <a:rPr sz="1550" b="1">
+              <a:rPr sz="1600" b="1">
                 <a:solidFill>
                   <a:srgbClr val="F4F8FC"/>
                 </a:solidFill>
@@ -12176,7 +12358,7 @@
         <p:spPr>
           <a:xfrm>
             <a:off x="640080" y="5074920"/>
-            <a:ext cx="5321808" cy="475488"/>
+            <a:ext cx="3493008" cy="512064"/>
           </a:xfrm>
           <a:prstGeom prst="roundRect">
             <a:avLst>
@@ -12212,7 +12394,7 @@
           <a:p>
             <a:pPr algn="l"/>
             <a:r>
-              <a:rPr sz="1250" b="0">
+              <a:rPr sz="1600" b="0">
                 <a:solidFill>
                   <a:srgbClr val="F4F8FC"/>
                 </a:solidFill>
@@ -12231,8 +12413,8 @@
         </p:nvSpPr>
         <p:spPr>
           <a:xfrm>
-            <a:off x="6236208" y="5074920"/>
-            <a:ext cx="5321808" cy="475488"/>
+            <a:off x="4315968" y="5074920"/>
+            <a:ext cx="3493008" cy="512064"/>
           </a:xfrm>
           <a:prstGeom prst="roundRect">
             <a:avLst>
@@ -12268,7 +12450,7 @@
           <a:p>
             <a:pPr algn="l"/>
             <a:r>
-              <a:rPr sz="1250" b="0">
+              <a:rPr sz="1600" b="0">
                 <a:solidFill>
                   <a:srgbClr val="F4F8FC"/>
                 </a:solidFill>
@@ -12287,8 +12469,8 @@
         </p:nvSpPr>
         <p:spPr>
           <a:xfrm>
-            <a:off x="640080" y="5696712"/>
-            <a:ext cx="5321808" cy="475488"/>
+            <a:off x="7991855" y="5074920"/>
+            <a:ext cx="3493008" cy="512064"/>
           </a:xfrm>
           <a:prstGeom prst="roundRect">
             <a:avLst>
@@ -12324,7 +12506,7 @@
           <a:p>
             <a:pPr algn="l"/>
             <a:r>
-              <a:rPr sz="1250" b="0">
+              <a:rPr sz="1600" b="0">
                 <a:solidFill>
                   <a:srgbClr val="F4F8FC"/>
                 </a:solidFill>
@@ -12343,8 +12525,8 @@
         </p:nvSpPr>
         <p:spPr>
           <a:xfrm>
-            <a:off x="6236208" y="5696712"/>
-            <a:ext cx="5321808" cy="475488"/>
+            <a:off x="640080" y="5696712"/>
+            <a:ext cx="3493008" cy="512064"/>
           </a:xfrm>
           <a:prstGeom prst="roundRect">
             <a:avLst>
@@ -12380,7 +12562,7 @@
           <a:p>
             <a:pPr algn="l"/>
             <a:r>
-              <a:rPr sz="1250" b="0">
+              <a:rPr sz="1600" b="0">
                 <a:solidFill>
                   <a:srgbClr val="F4F8FC"/>
                 </a:solidFill>
@@ -12436,13 +12618,13 @@
           <a:p>
             <a:pPr algn="ctr"/>
             <a:r>
-              <a:rPr sz="1300" b="1">
+              <a:rPr sz="1250" b="1">
                 <a:solidFill>
                   <a:srgbClr val="F4F8FC"/>
                 </a:solidFill>
                 <a:latin typeface="Microsoft JhengHei"/>
               </a:rPr>
-              <a:t>資料流程 1</a:t>
+              <a:t>Webhook 接收</a:t>
             </a:r>
           </a:p>
         </p:txBody>
@@ -12492,13 +12674,13 @@
           <a:p>
             <a:pPr algn="ctr"/>
             <a:r>
-              <a:rPr sz="1300" b="1">
+              <a:rPr sz="1250" b="1">
                 <a:solidFill>
                   <a:srgbClr val="F4F8FC"/>
                 </a:solidFill>
                 <a:latin typeface="Microsoft JhengHei"/>
               </a:rPr>
-              <a:t>資料流程 2</a:t>
+              <a:t>簽章與群組 mention 驗證</a:t>
             </a:r>
           </a:p>
         </p:txBody>
@@ -12548,13 +12730,13 @@
           <a:p>
             <a:pPr algn="ctr"/>
             <a:r>
-              <a:rPr sz="1300" b="1">
+              <a:rPr sz="1250" b="1">
                 <a:solidFill>
                   <a:srgbClr val="F4F8FC"/>
                 </a:solidFill>
                 <a:latin typeface="Microsoft JhengHei"/>
               </a:rPr>
-              <a:t>資料流程 3</a:t>
+              <a:t>Queue 入列</a:t>
             </a:r>
           </a:p>
         </p:txBody>
@@ -12604,13 +12786,13 @@
           <a:p>
             <a:pPr algn="ctr"/>
             <a:r>
-              <a:rPr sz="1300" b="1">
+              <a:rPr sz="1250" b="1">
                 <a:solidFill>
                   <a:srgbClr val="F4F8FC"/>
                 </a:solidFill>
                 <a:latin typeface="Microsoft JhengHei"/>
               </a:rPr>
-              <a:t>資料流程 4</a:t>
+              <a:t>AI 或資料來源處理</a:t>
             </a:r>
           </a:p>
         </p:txBody>
@@ -12660,13 +12842,13 @@
           <a:p>
             <a:pPr algn="ctr"/>
             <a:r>
-              <a:rPr sz="1300" b="1">
+              <a:rPr sz="1250" b="1">
                 <a:solidFill>
                   <a:srgbClr val="F4F8FC"/>
                 </a:solidFill>
                 <a:latin typeface="Microsoft JhengHei"/>
               </a:rPr>
-              <a:t>資料流程 5</a:t>
+              <a:t>LINE reply 與 push fallback</a:t>
             </a:r>
           </a:p>
         </p:txBody>
@@ -12716,13 +12898,13 @@
           <a:p>
             <a:pPr algn="ctr"/>
             <a:r>
-              <a:rPr sz="1300" b="1">
+              <a:rPr sz="1250" b="1">
                 <a:solidFill>
                   <a:srgbClr val="F4F8FC"/>
                 </a:solidFill>
                 <a:latin typeface="Microsoft JhengHei"/>
               </a:rPr>
-              <a:t>資料流程 6</a:t>
+              <a:t>D1 與觀測紀錄</a:t>
             </a:r>
           </a:p>
         </p:txBody>
@@ -12745,6 +12927,7 @@
             <a:solidFill>
               <a:srgbClr val="4BA3FF"/>
             </a:solidFill>
+            <a:tailEnd type="triangle"/>
           </a:ln>
         </p:spPr>
         <p:style>
@@ -12780,6 +12963,7 @@
             <a:solidFill>
               <a:srgbClr val="4BA3FF"/>
             </a:solidFill>
+            <a:tailEnd type="triangle"/>
           </a:ln>
         </p:spPr>
         <p:style>
@@ -12815,6 +12999,7 @@
             <a:solidFill>
               <a:srgbClr val="4BA3FF"/>
             </a:solidFill>
+            <a:tailEnd type="triangle"/>
           </a:ln>
         </p:spPr>
         <p:style>
@@ -12850,6 +13035,7 @@
             <a:solidFill>
               <a:srgbClr val="4BA3FF"/>
             </a:solidFill>
+            <a:tailEnd type="triangle"/>
           </a:ln>
         </p:spPr>
         <p:style>
@@ -12885,6 +13071,7 @@
             <a:solidFill>
               <a:srgbClr val="4BA3FF"/>
             </a:solidFill>
+            <a:tailEnd type="triangle"/>
           </a:ln>
         </p:spPr>
         <p:style>
@@ -13086,7 +13273,7 @@
           <a:p>
             <a:pPr algn="l"/>
             <a:r>
-              <a:rPr sz="1550" b="1">
+              <a:rPr sz="1600" b="1">
                 <a:solidFill>
                   <a:srgbClr val="F4F8FC"/>
                 </a:solidFill>
@@ -13176,7 +13363,7 @@
         <p:spPr>
           <a:xfrm>
             <a:off x="640080" y="5074920"/>
-            <a:ext cx="5321808" cy="475488"/>
+            <a:ext cx="3493008" cy="512064"/>
           </a:xfrm>
           <a:prstGeom prst="roundRect">
             <a:avLst>
@@ -13212,7 +13399,7 @@
           <a:p>
             <a:pPr algn="l"/>
             <a:r>
-              <a:rPr sz="1250" b="0">
+              <a:rPr sz="1600" b="0">
                 <a:solidFill>
                   <a:srgbClr val="F4F8FC"/>
                 </a:solidFill>
@@ -13231,8 +13418,8 @@
         </p:nvSpPr>
         <p:spPr>
           <a:xfrm>
-            <a:off x="6236208" y="5074920"/>
-            <a:ext cx="5321808" cy="475488"/>
+            <a:off x="4315968" y="5074920"/>
+            <a:ext cx="3493008" cy="512064"/>
           </a:xfrm>
           <a:prstGeom prst="roundRect">
             <a:avLst>
@@ -13268,7 +13455,7 @@
           <a:p>
             <a:pPr algn="l"/>
             <a:r>
-              <a:rPr sz="1250" b="0">
+              <a:rPr sz="1600" b="0">
                 <a:solidFill>
                   <a:srgbClr val="F4F8FC"/>
                 </a:solidFill>
@@ -13287,8 +13474,8 @@
         </p:nvSpPr>
         <p:spPr>
           <a:xfrm>
-            <a:off x="640080" y="5696712"/>
-            <a:ext cx="5321808" cy="475488"/>
+            <a:off x="7991855" y="5074920"/>
+            <a:ext cx="3493008" cy="512064"/>
           </a:xfrm>
           <a:prstGeom prst="roundRect">
             <a:avLst>
@@ -13324,7 +13511,7 @@
           <a:p>
             <a:pPr algn="l"/>
             <a:r>
-              <a:rPr sz="1250" b="0">
+              <a:rPr sz="1600" b="0">
                 <a:solidFill>
                   <a:srgbClr val="F4F8FC"/>
                 </a:solidFill>
@@ -13343,8 +13530,8 @@
         </p:nvSpPr>
         <p:spPr>
           <a:xfrm>
-            <a:off x="6236208" y="5696712"/>
-            <a:ext cx="5321808" cy="475488"/>
+            <a:off x="640080" y="5696712"/>
+            <a:ext cx="3493008" cy="512064"/>
           </a:xfrm>
           <a:prstGeom prst="roundRect">
             <a:avLst>
@@ -13380,7 +13567,7 @@
           <a:p>
             <a:pPr algn="l"/>
             <a:r>
-              <a:rPr sz="1250" b="0">
+              <a:rPr sz="1600" b="0">
                 <a:solidFill>
                   <a:srgbClr val="F4F8FC"/>
                 </a:solidFill>
@@ -13521,6 +13708,7 @@
             <a:solidFill>
               <a:srgbClr val="21D4B4"/>
             </a:solidFill>
+            <a:tailEnd type="triangle"/>
           </a:ln>
         </p:spPr>
         <p:style>
@@ -13612,6 +13800,7 @@
             <a:solidFill>
               <a:srgbClr val="21D4B4"/>
             </a:solidFill>
+            <a:tailEnd type="triangle"/>
           </a:ln>
         </p:spPr>
         <p:style>
@@ -13703,6 +13892,7 @@
             <a:solidFill>
               <a:srgbClr val="21D4B4"/>
             </a:solidFill>
+            <a:tailEnd type="triangle"/>
           </a:ln>
         </p:spPr>
         <p:style>
@@ -13904,7 +14094,7 @@
           <a:p>
             <a:pPr algn="l"/>
             <a:r>
-              <a:rPr sz="1550" b="1">
+              <a:rPr sz="1600" b="1">
                 <a:solidFill>
                   <a:srgbClr val="F4F8FC"/>
                 </a:solidFill>
@@ -13994,7 +14184,7 @@
         <p:spPr>
           <a:xfrm>
             <a:off x="640080" y="5074920"/>
-            <a:ext cx="5321808" cy="475488"/>
+            <a:ext cx="3493008" cy="512064"/>
           </a:xfrm>
           <a:prstGeom prst="roundRect">
             <a:avLst>
@@ -14030,7 +14220,7 @@
           <a:p>
             <a:pPr algn="l"/>
             <a:r>
-              <a:rPr sz="1250" b="0">
+              <a:rPr sz="1600" b="0">
                 <a:solidFill>
                   <a:srgbClr val="F4F8FC"/>
                 </a:solidFill>
@@ -14049,8 +14239,8 @@
         </p:nvSpPr>
         <p:spPr>
           <a:xfrm>
-            <a:off x="6236208" y="5074920"/>
-            <a:ext cx="5321808" cy="475488"/>
+            <a:off x="4315968" y="5074920"/>
+            <a:ext cx="3493008" cy="512064"/>
           </a:xfrm>
           <a:prstGeom prst="roundRect">
             <a:avLst>
@@ -14086,7 +14276,7 @@
           <a:p>
             <a:pPr algn="l"/>
             <a:r>
-              <a:rPr sz="1250" b="0">
+              <a:rPr sz="1600" b="0">
                 <a:solidFill>
                   <a:srgbClr val="F4F8FC"/>
                 </a:solidFill>
@@ -14105,8 +14295,8 @@
         </p:nvSpPr>
         <p:spPr>
           <a:xfrm>
-            <a:off x="640080" y="5696712"/>
-            <a:ext cx="5321808" cy="475488"/>
+            <a:off x="7991855" y="5074920"/>
+            <a:ext cx="3493008" cy="512064"/>
           </a:xfrm>
           <a:prstGeom prst="roundRect">
             <a:avLst>
@@ -14142,7 +14332,7 @@
           <a:p>
             <a:pPr algn="l"/>
             <a:r>
-              <a:rPr sz="1250" b="0">
+              <a:rPr sz="1600" b="0">
                 <a:solidFill>
                   <a:srgbClr val="F4F8FC"/>
                 </a:solidFill>
@@ -14161,8 +14351,8 @@
         </p:nvSpPr>
         <p:spPr>
           <a:xfrm>
-            <a:off x="6236208" y="5696712"/>
-            <a:ext cx="5321808" cy="475488"/>
+            <a:off x="640080" y="5696712"/>
+            <a:ext cx="3493008" cy="512064"/>
           </a:xfrm>
           <a:prstGeom prst="roundRect">
             <a:avLst>
@@ -14198,7 +14388,7 @@
           <a:p>
             <a:pPr algn="l"/>
             <a:r>
-              <a:rPr sz="1250" b="0">
+              <a:rPr sz="1600" b="0">
                 <a:solidFill>
                   <a:srgbClr val="F4F8FC"/>
                 </a:solidFill>
@@ -14341,6 +14531,7 @@
             <a:solidFill>
               <a:srgbClr val="FF6B6B"/>
             </a:solidFill>
+            <a:tailEnd type="triangle"/>
           </a:ln>
         </p:spPr>
         <p:style>
@@ -14433,6 +14624,7 @@
             <a:solidFill>
               <a:srgbClr val="4BA3FF"/>
             </a:solidFill>
+            <a:tailEnd type="triangle"/>
           </a:ln>
         </p:spPr>
         <p:style>
@@ -14634,7 +14826,7 @@
           <a:p>
             <a:pPr algn="l"/>
             <a:r>
-              <a:rPr sz="1550" b="1">
+              <a:rPr sz="1600" b="1">
                 <a:solidFill>
                   <a:srgbClr val="F4F8FC"/>
                 </a:solidFill>
@@ -14723,8 +14915,8 @@
         </p:nvSpPr>
         <p:spPr>
           <a:xfrm>
-            <a:off x="640080" y="1874519"/>
-            <a:ext cx="5321808" cy="2007107"/>
+            <a:off x="640080" y="5074920"/>
+            <a:ext cx="3493008" cy="512064"/>
           </a:xfrm>
           <a:prstGeom prst="roundRect">
             <a:avLst>
@@ -14760,7 +14952,7 @@
           <a:p>
             <a:pPr algn="l"/>
             <a:r>
-              <a:rPr sz="1550" b="0">
+              <a:rPr sz="1600" b="0">
                 <a:solidFill>
                   <a:srgbClr val="F4F8FC"/>
                 </a:solidFill>
@@ -14779,8 +14971,8 @@
         </p:nvSpPr>
         <p:spPr>
           <a:xfrm>
-            <a:off x="6236208" y="1874519"/>
-            <a:ext cx="5321808" cy="2007107"/>
+            <a:off x="4315968" y="5074920"/>
+            <a:ext cx="3493008" cy="512064"/>
           </a:xfrm>
           <a:prstGeom prst="roundRect">
             <a:avLst>
@@ -14816,7 +15008,7 @@
           <a:p>
             <a:pPr algn="l"/>
             <a:r>
-              <a:rPr sz="1550" b="0">
+              <a:rPr sz="1600" b="0">
                 <a:solidFill>
                   <a:srgbClr val="F4F8FC"/>
                 </a:solidFill>
@@ -14835,8 +15027,8 @@
         </p:nvSpPr>
         <p:spPr>
           <a:xfrm>
-            <a:off x="640080" y="4027931"/>
-            <a:ext cx="5321808" cy="2007107"/>
+            <a:off x="7991855" y="5074920"/>
+            <a:ext cx="3493008" cy="512064"/>
           </a:xfrm>
           <a:prstGeom prst="roundRect">
             <a:avLst>
@@ -14872,7 +15064,7 @@
           <a:p>
             <a:pPr algn="l"/>
             <a:r>
-              <a:rPr sz="1550" b="0">
+              <a:rPr sz="1600" b="0">
                 <a:solidFill>
                   <a:srgbClr val="F4F8FC"/>
                 </a:solidFill>
@@ -14891,8 +15083,8 @@
         </p:nvSpPr>
         <p:spPr>
           <a:xfrm>
-            <a:off x="6236208" y="4027931"/>
-            <a:ext cx="5321808" cy="2007107"/>
+            <a:off x="640080" y="5696712"/>
+            <a:ext cx="3493008" cy="512064"/>
           </a:xfrm>
           <a:prstGeom prst="roundRect">
             <a:avLst>
@@ -14928,13 +15120,181 @@
           <a:p>
             <a:pPr algn="l"/>
             <a:r>
-              <a:rPr sz="1550" b="0">
+              <a:rPr sz="1600" b="0">
                 <a:solidFill>
                   <a:srgbClr val="F4F8FC"/>
                 </a:solidFill>
                 <a:latin typeface="Microsoft JhengHei"/>
               </a:rPr>
               <a:t>健康與緊急情境僅提供一般資訊並提醒尋求專業協助</a:t>
+            </a:r>
+          </a:p>
+        </p:txBody>
+      </p:sp>
+      <p:sp>
+        <p:nvSpPr>
+          <p:cNvPr id="12" name="model-boundary-primary"/>
+          <p:cNvSpPr/>
+          <p:nvPr/>
+        </p:nvSpPr>
+        <p:spPr>
+          <a:xfrm>
+            <a:off x="822960" y="2148840"/>
+            <a:ext cx="2788920" cy="621792"/>
+          </a:xfrm>
+          <a:prstGeom prst="roundRect">
+            <a:avLst>
+              <a:gd name="adj" fmla="val 10000"/>
+            </a:avLst>
+          </a:prstGeom>
+          <a:solidFill>
+            <a:srgbClr val="102B46"/>
+          </a:solidFill>
+          <a:ln w="13970">
+            <a:solidFill>
+              <a:srgbClr val="21D4B4"/>
+            </a:solidFill>
+          </a:ln>
+        </p:spPr>
+        <p:style>
+          <a:lnRef idx="1">
+            <a:schemeClr val="accent1"/>
+          </a:lnRef>
+          <a:fillRef idx="3">
+            <a:schemeClr val="accent1"/>
+          </a:fillRef>
+          <a:effectRef idx="2">
+            <a:schemeClr val="accent1"/>
+          </a:effectRef>
+          <a:fontRef idx="minor">
+            <a:schemeClr val="lt1"/>
+          </a:fontRef>
+        </p:style>
+        <p:txBody>
+          <a:bodyPr rtlCol="0" anchor="ctr" wrap="square" lIns="109728" rIns="109728" tIns="64008" bIns="64008"/>
+          <a:lstStyle/>
+          <a:p>
+            <a:pPr algn="ctr"/>
+            <a:r>
+              <a:rPr sz="1400" b="1">
+                <a:solidFill>
+                  <a:srgbClr val="F4F8FC"/>
+                </a:solidFill>
+                <a:latin typeface="Microsoft JhengHei"/>
+              </a:rPr>
+              <a:t>主要模型</a:t>
+            </a:r>
+          </a:p>
+        </p:txBody>
+      </p:sp>
+      <p:sp>
+        <p:nvSpPr>
+          <p:cNvPr id="13" name="model-boundary-fallback"/>
+          <p:cNvSpPr/>
+          <p:nvPr/>
+        </p:nvSpPr>
+        <p:spPr>
+          <a:xfrm>
+            <a:off x="4572000" y="2148840"/>
+            <a:ext cx="2788920" cy="621792"/>
+          </a:xfrm>
+          <a:prstGeom prst="roundRect">
+            <a:avLst>
+              <a:gd name="adj" fmla="val 10000"/>
+            </a:avLst>
+          </a:prstGeom>
+          <a:solidFill>
+            <a:srgbClr val="102B46"/>
+          </a:solidFill>
+          <a:ln w="13970">
+            <a:solidFill>
+              <a:srgbClr val="4BA3FF"/>
+            </a:solidFill>
+          </a:ln>
+        </p:spPr>
+        <p:style>
+          <a:lnRef idx="1">
+            <a:schemeClr val="accent1"/>
+          </a:lnRef>
+          <a:fillRef idx="3">
+            <a:schemeClr val="accent1"/>
+          </a:fillRef>
+          <a:effectRef idx="2">
+            <a:schemeClr val="accent1"/>
+          </a:effectRef>
+          <a:fontRef idx="minor">
+            <a:schemeClr val="lt1"/>
+          </a:fontRef>
+        </p:style>
+        <p:txBody>
+          <a:bodyPr rtlCol="0" anchor="ctr" wrap="square" lIns="109728" rIns="109728" tIns="64008" bIns="64008"/>
+          <a:lstStyle/>
+          <a:p>
+            <a:pPr algn="ctr"/>
+            <a:r>
+              <a:rPr sz="1400" b="1">
+                <a:solidFill>
+                  <a:srgbClr val="F4F8FC"/>
+                </a:solidFill>
+                <a:latin typeface="Microsoft JhengHei"/>
+              </a:rPr>
+              <a:t>備援模型</a:t>
+            </a:r>
+          </a:p>
+        </p:txBody>
+      </p:sp>
+      <p:sp>
+        <p:nvSpPr>
+          <p:cNvPr id="14" name="model-boundary-policy"/>
+          <p:cNvSpPr/>
+          <p:nvPr/>
+        </p:nvSpPr>
+        <p:spPr>
+          <a:xfrm>
+            <a:off x="8321040" y="2148840"/>
+            <a:ext cx="2788920" cy="621792"/>
+          </a:xfrm>
+          <a:prstGeom prst="roundRect">
+            <a:avLst>
+              <a:gd name="adj" fmla="val 10000"/>
+            </a:avLst>
+          </a:prstGeom>
+          <a:solidFill>
+            <a:srgbClr val="102B46"/>
+          </a:solidFill>
+          <a:ln w="13970">
+            <a:solidFill>
+              <a:srgbClr val="FFBE55"/>
+            </a:solidFill>
+          </a:ln>
+        </p:spPr>
+        <p:style>
+          <a:lnRef idx="1">
+            <a:schemeClr val="accent1"/>
+          </a:lnRef>
+          <a:fillRef idx="3">
+            <a:schemeClr val="accent1"/>
+          </a:fillRef>
+          <a:effectRef idx="2">
+            <a:schemeClr val="accent1"/>
+          </a:effectRef>
+          <a:fontRef idx="minor">
+            <a:schemeClr val="lt1"/>
+          </a:fontRef>
+        </p:style>
+        <p:txBody>
+          <a:bodyPr rtlCol="0" anchor="ctr" wrap="square" lIns="109728" rIns="109728" tIns="64008" bIns="64008"/>
+          <a:lstStyle/>
+          <a:p>
+            <a:pPr algn="ctr"/>
+            <a:r>
+              <a:rPr sz="1400" b="1">
+                <a:solidFill>
+                  <a:srgbClr val="F4F8FC"/>
+                </a:solidFill>
+                <a:latin typeface="Microsoft JhengHei"/>
+              </a:rPr>
+              <a:t>回答政策</a:t>
             </a:r>
           </a:p>
         </p:txBody>
@@ -15123,7 +15483,7 @@
           <a:p>
             <a:pPr algn="l"/>
             <a:r>
-              <a:rPr sz="1550" b="1">
+              <a:rPr sz="1600" b="1">
                 <a:solidFill>
                   <a:srgbClr val="F4F8FC"/>
                 </a:solidFill>
@@ -15212,8 +15572,8 @@
         </p:nvSpPr>
         <p:spPr>
           <a:xfrm>
-            <a:off x="640080" y="1874519"/>
-            <a:ext cx="5321808" cy="2007107"/>
+            <a:off x="640080" y="5074920"/>
+            <a:ext cx="3493008" cy="512064"/>
           </a:xfrm>
           <a:prstGeom prst="roundRect">
             <a:avLst>
@@ -15249,7 +15609,7 @@
           <a:p>
             <a:pPr algn="l"/>
             <a:r>
-              <a:rPr sz="1550" b="0">
+              <a:rPr sz="1600" b="0">
                 <a:solidFill>
                   <a:srgbClr val="F4F8FC"/>
                 </a:solidFill>
@@ -15268,8 +15628,8 @@
         </p:nvSpPr>
         <p:spPr>
           <a:xfrm>
-            <a:off x="6236208" y="1874519"/>
-            <a:ext cx="5321808" cy="2007107"/>
+            <a:off x="4315968" y="5074920"/>
+            <a:ext cx="3493008" cy="512064"/>
           </a:xfrm>
           <a:prstGeom prst="roundRect">
             <a:avLst>
@@ -15305,7 +15665,7 @@
           <a:p>
             <a:pPr algn="l"/>
             <a:r>
-              <a:rPr sz="1550" b="0">
+              <a:rPr sz="1600" b="0">
                 <a:solidFill>
                   <a:srgbClr val="F4F8FC"/>
                 </a:solidFill>
@@ -15324,8 +15684,8 @@
         </p:nvSpPr>
         <p:spPr>
           <a:xfrm>
-            <a:off x="640080" y="4027931"/>
-            <a:ext cx="5321808" cy="2007107"/>
+            <a:off x="7991855" y="5074920"/>
+            <a:ext cx="3493008" cy="512064"/>
           </a:xfrm>
           <a:prstGeom prst="roundRect">
             <a:avLst>
@@ -15361,7 +15721,7 @@
           <a:p>
             <a:pPr algn="l"/>
             <a:r>
-              <a:rPr sz="1550" b="0">
+              <a:rPr sz="1600" b="0">
                 <a:solidFill>
                   <a:srgbClr val="F4F8FC"/>
                 </a:solidFill>
@@ -15380,8 +15740,8 @@
         </p:nvSpPr>
         <p:spPr>
           <a:xfrm>
-            <a:off x="6236208" y="4027931"/>
-            <a:ext cx="5321808" cy="2007107"/>
+            <a:off x="640080" y="5696712"/>
+            <a:ext cx="3493008" cy="512064"/>
           </a:xfrm>
           <a:prstGeom prst="roundRect">
             <a:avLst>
@@ -15417,7 +15777,7 @@
           <a:p>
             <a:pPr algn="l"/>
             <a:r>
-              <a:rPr sz="1550" b="0">
+              <a:rPr sz="1600" b="0">
                 <a:solidFill>
                   <a:srgbClr val="F4F8FC"/>
                 </a:solidFill>
@@ -15428,6 +15788,338 @@
           </a:p>
         </p:txBody>
       </p:sp>
+      <p:sp>
+        <p:nvSpPr>
+          <p:cNvPr id="12" name="weather-cache-step-intent"/>
+          <p:cNvSpPr/>
+          <p:nvPr/>
+        </p:nvSpPr>
+        <p:spPr>
+          <a:xfrm>
+            <a:off x="777240" y="2148840"/>
+            <a:ext cx="2240280" cy="566928"/>
+          </a:xfrm>
+          <a:prstGeom prst="roundRect">
+            <a:avLst>
+              <a:gd name="adj" fmla="val 10000"/>
+            </a:avLst>
+          </a:prstGeom>
+          <a:solidFill>
+            <a:srgbClr val="102B46"/>
+          </a:solidFill>
+          <a:ln w="13970">
+            <a:solidFill>
+              <a:srgbClr val="21D4B4"/>
+            </a:solidFill>
+          </a:ln>
+        </p:spPr>
+        <p:style>
+          <a:lnRef idx="1">
+            <a:schemeClr val="accent1"/>
+          </a:lnRef>
+          <a:fillRef idx="3">
+            <a:schemeClr val="accent1"/>
+          </a:fillRef>
+          <a:effectRef idx="2">
+            <a:schemeClr val="accent1"/>
+          </a:effectRef>
+          <a:fontRef idx="minor">
+            <a:schemeClr val="lt1"/>
+          </a:fontRef>
+        </p:style>
+        <p:txBody>
+          <a:bodyPr rtlCol="0" anchor="ctr" wrap="square" lIns="109728" rIns="109728" tIns="64008" bIns="64008"/>
+          <a:lstStyle/>
+          <a:p>
+            <a:pPr algn="ctr"/>
+            <a:r>
+              <a:rPr sz="1350" b="1">
+                <a:solidFill>
+                  <a:srgbClr val="F4F8FC"/>
+                </a:solidFill>
+                <a:latin typeface="Microsoft JhengHei"/>
+              </a:rPr>
+              <a:t>意圖辨識</a:t>
+            </a:r>
+          </a:p>
+        </p:txBody>
+      </p:sp>
+      <p:sp>
+        <p:nvSpPr>
+          <p:cNvPr id="13" name="weather-cache-step-cache-read"/>
+          <p:cNvSpPr/>
+          <p:nvPr/>
+        </p:nvSpPr>
+        <p:spPr>
+          <a:xfrm>
+            <a:off x="3611880" y="2148840"/>
+            <a:ext cx="2240280" cy="566928"/>
+          </a:xfrm>
+          <a:prstGeom prst="roundRect">
+            <a:avLst>
+              <a:gd name="adj" fmla="val 10000"/>
+            </a:avLst>
+          </a:prstGeom>
+          <a:solidFill>
+            <a:srgbClr val="102B46"/>
+          </a:solidFill>
+          <a:ln w="13970">
+            <a:solidFill>
+              <a:srgbClr val="21D4B4"/>
+            </a:solidFill>
+          </a:ln>
+        </p:spPr>
+        <p:style>
+          <a:lnRef idx="1">
+            <a:schemeClr val="accent1"/>
+          </a:lnRef>
+          <a:fillRef idx="3">
+            <a:schemeClr val="accent1"/>
+          </a:fillRef>
+          <a:effectRef idx="2">
+            <a:schemeClr val="accent1"/>
+          </a:effectRef>
+          <a:fontRef idx="minor">
+            <a:schemeClr val="lt1"/>
+          </a:fontRef>
+        </p:style>
+        <p:txBody>
+          <a:bodyPr rtlCol="0" anchor="ctr" wrap="square" lIns="109728" rIns="109728" tIns="64008" bIns="64008"/>
+          <a:lstStyle/>
+          <a:p>
+            <a:pPr algn="ctr"/>
+            <a:r>
+              <a:rPr sz="1350" b="1">
+                <a:solidFill>
+                  <a:srgbClr val="F4F8FC"/>
+                </a:solidFill>
+                <a:latin typeface="Microsoft JhengHei"/>
+              </a:rPr>
+              <a:t>快取讀取</a:t>
+            </a:r>
+          </a:p>
+        </p:txBody>
+      </p:sp>
+      <p:cxnSp>
+        <p:nvCxnSpPr>
+          <p:cNvPr id="14" name="weather-cache-connector-1"/>
+          <p:cNvCxnSpPr/>
+          <p:nvPr/>
+        </p:nvCxnSpPr>
+        <p:spPr>
+          <a:xfrm>
+            <a:off x="3017520" y="2432304"/>
+            <a:ext cx="594360" cy="0"/>
+          </a:xfrm>
+          <a:prstGeom prst="line">
+            <a:avLst/>
+          </a:prstGeom>
+          <a:ln w="22860">
+            <a:solidFill>
+              <a:srgbClr val="4BA3FF"/>
+            </a:solidFill>
+            <a:tailEnd type="triangle"/>
+          </a:ln>
+        </p:spPr>
+        <p:style>
+          <a:lnRef idx="2">
+            <a:schemeClr val="accent1"/>
+          </a:lnRef>
+          <a:fillRef idx="0">
+            <a:schemeClr val="accent1"/>
+          </a:fillRef>
+          <a:effectRef idx="1">
+            <a:schemeClr val="accent1"/>
+          </a:effectRef>
+          <a:fontRef idx="minor">
+            <a:schemeClr val="tx1"/>
+          </a:fontRef>
+        </p:style>
+      </p:cxnSp>
+      <p:sp>
+        <p:nvSpPr>
+          <p:cNvPr id="15" name="weather-cache-step-provider"/>
+          <p:cNvSpPr/>
+          <p:nvPr/>
+        </p:nvSpPr>
+        <p:spPr>
+          <a:xfrm>
+            <a:off x="6446520" y="2148840"/>
+            <a:ext cx="2240280" cy="566928"/>
+          </a:xfrm>
+          <a:prstGeom prst="roundRect">
+            <a:avLst>
+              <a:gd name="adj" fmla="val 10000"/>
+            </a:avLst>
+          </a:prstGeom>
+          <a:solidFill>
+            <a:srgbClr val="102B46"/>
+          </a:solidFill>
+          <a:ln w="13970">
+            <a:solidFill>
+              <a:srgbClr val="4BA3FF"/>
+            </a:solidFill>
+          </a:ln>
+        </p:spPr>
+        <p:style>
+          <a:lnRef idx="1">
+            <a:schemeClr val="accent1"/>
+          </a:lnRef>
+          <a:fillRef idx="3">
+            <a:schemeClr val="accent1"/>
+          </a:fillRef>
+          <a:effectRef idx="2">
+            <a:schemeClr val="accent1"/>
+          </a:effectRef>
+          <a:fontRef idx="minor">
+            <a:schemeClr val="lt1"/>
+          </a:fontRef>
+        </p:style>
+        <p:txBody>
+          <a:bodyPr rtlCol="0" anchor="ctr" wrap="square" lIns="109728" rIns="109728" tIns="64008" bIns="64008"/>
+          <a:lstStyle/>
+          <a:p>
+            <a:pPr algn="ctr"/>
+            <a:r>
+              <a:rPr sz="1350" b="1">
+                <a:solidFill>
+                  <a:srgbClr val="F4F8FC"/>
+                </a:solidFill>
+                <a:latin typeface="Microsoft JhengHei"/>
+              </a:rPr>
+              <a:t>Open-Meteo</a:t>
+            </a:r>
+          </a:p>
+        </p:txBody>
+      </p:sp>
+      <p:cxnSp>
+        <p:nvCxnSpPr>
+          <p:cNvPr id="16" name="weather-cache-connector-2"/>
+          <p:cNvCxnSpPr/>
+          <p:nvPr/>
+        </p:nvCxnSpPr>
+        <p:spPr>
+          <a:xfrm>
+            <a:off x="5852160" y="2432304"/>
+            <a:ext cx="594360" cy="0"/>
+          </a:xfrm>
+          <a:prstGeom prst="line">
+            <a:avLst/>
+          </a:prstGeom>
+          <a:ln w="22860">
+            <a:solidFill>
+              <a:srgbClr val="4BA3FF"/>
+            </a:solidFill>
+            <a:tailEnd type="triangle"/>
+          </a:ln>
+        </p:spPr>
+        <p:style>
+          <a:lnRef idx="2">
+            <a:schemeClr val="accent1"/>
+          </a:lnRef>
+          <a:fillRef idx="0">
+            <a:schemeClr val="accent1"/>
+          </a:fillRef>
+          <a:effectRef idx="1">
+            <a:schemeClr val="accent1"/>
+          </a:effectRef>
+          <a:fontRef idx="minor">
+            <a:schemeClr val="tx1"/>
+          </a:fontRef>
+        </p:style>
+      </p:cxnSp>
+      <p:sp>
+        <p:nvSpPr>
+          <p:cNvPr id="17" name="weather-cache-step-cache-write"/>
+          <p:cNvSpPr/>
+          <p:nvPr/>
+        </p:nvSpPr>
+        <p:spPr>
+          <a:xfrm>
+            <a:off x="9281160" y="2148840"/>
+            <a:ext cx="2240280" cy="566928"/>
+          </a:xfrm>
+          <a:prstGeom prst="roundRect">
+            <a:avLst>
+              <a:gd name="adj" fmla="val 10000"/>
+            </a:avLst>
+          </a:prstGeom>
+          <a:solidFill>
+            <a:srgbClr val="102B46"/>
+          </a:solidFill>
+          <a:ln w="13970">
+            <a:solidFill>
+              <a:srgbClr val="4BA3FF"/>
+            </a:solidFill>
+          </a:ln>
+        </p:spPr>
+        <p:style>
+          <a:lnRef idx="1">
+            <a:schemeClr val="accent1"/>
+          </a:lnRef>
+          <a:fillRef idx="3">
+            <a:schemeClr val="accent1"/>
+          </a:fillRef>
+          <a:effectRef idx="2">
+            <a:schemeClr val="accent1"/>
+          </a:effectRef>
+          <a:fontRef idx="minor">
+            <a:schemeClr val="lt1"/>
+          </a:fontRef>
+        </p:style>
+        <p:txBody>
+          <a:bodyPr rtlCol="0" anchor="ctr" wrap="square" lIns="109728" rIns="109728" tIns="64008" bIns="64008"/>
+          <a:lstStyle/>
+          <a:p>
+            <a:pPr algn="ctr"/>
+            <a:r>
+              <a:rPr sz="1350" b="1">
+                <a:solidFill>
+                  <a:srgbClr val="F4F8FC"/>
+                </a:solidFill>
+                <a:latin typeface="Microsoft JhengHei"/>
+              </a:rPr>
+              <a:t>快取寫入</a:t>
+            </a:r>
+          </a:p>
+        </p:txBody>
+      </p:sp>
+      <p:cxnSp>
+        <p:nvCxnSpPr>
+          <p:cNvPr id="18" name="weather-cache-connector-3"/>
+          <p:cNvCxnSpPr/>
+          <p:nvPr/>
+        </p:nvCxnSpPr>
+        <p:spPr>
+          <a:xfrm>
+            <a:off x="8686800" y="2432304"/>
+            <a:ext cx="594360" cy="0"/>
+          </a:xfrm>
+          <a:prstGeom prst="line">
+            <a:avLst/>
+          </a:prstGeom>
+          <a:ln w="22860">
+            <a:solidFill>
+              <a:srgbClr val="4BA3FF"/>
+            </a:solidFill>
+            <a:tailEnd type="triangle"/>
+          </a:ln>
+        </p:spPr>
+        <p:style>
+          <a:lnRef idx="2">
+            <a:schemeClr val="accent1"/>
+          </a:lnRef>
+          <a:fillRef idx="0">
+            <a:schemeClr val="accent1"/>
+          </a:fillRef>
+          <a:effectRef idx="1">
+            <a:schemeClr val="accent1"/>
+          </a:effectRef>
+          <a:fontRef idx="minor">
+            <a:schemeClr val="tx1"/>
+          </a:fontRef>
+        </p:style>
+      </p:cxnSp>
     </p:spTree>
   </p:cSld>
   <p:clrMapOvr>
@@ -15612,7 +16304,7 @@
           <a:p>
             <a:pPr algn="l"/>
             <a:r>
-              <a:rPr sz="1550" b="1">
+              <a:rPr sz="1600" b="1">
                 <a:solidFill>
                   <a:srgbClr val="F4F8FC"/>
                 </a:solidFill>
@@ -15702,7 +16394,7 @@
         <p:spPr>
           <a:xfrm>
             <a:off x="640080" y="5074920"/>
-            <a:ext cx="5321808" cy="475488"/>
+            <a:ext cx="3493008" cy="512064"/>
           </a:xfrm>
           <a:prstGeom prst="roundRect">
             <a:avLst>
@@ -15738,7 +16430,7 @@
           <a:p>
             <a:pPr algn="l"/>
             <a:r>
-              <a:rPr sz="1250" b="0">
+              <a:rPr sz="1600" b="0">
                 <a:solidFill>
                   <a:srgbClr val="F4F8FC"/>
                 </a:solidFill>
@@ -15757,8 +16449,8 @@
         </p:nvSpPr>
         <p:spPr>
           <a:xfrm>
-            <a:off x="6236208" y="5074920"/>
-            <a:ext cx="5321808" cy="475488"/>
+            <a:off x="4315968" y="5074920"/>
+            <a:ext cx="3493008" cy="512064"/>
           </a:xfrm>
           <a:prstGeom prst="roundRect">
             <a:avLst>
@@ -15794,7 +16486,7 @@
           <a:p>
             <a:pPr algn="l"/>
             <a:r>
-              <a:rPr sz="1250" b="0">
+              <a:rPr sz="1600" b="0">
                 <a:solidFill>
                   <a:srgbClr val="F4F8FC"/>
                 </a:solidFill>
@@ -15813,8 +16505,8 @@
         </p:nvSpPr>
         <p:spPr>
           <a:xfrm>
-            <a:off x="640080" y="5696712"/>
-            <a:ext cx="5321808" cy="475488"/>
+            <a:off x="7991855" y="5074920"/>
+            <a:ext cx="3493008" cy="512064"/>
           </a:xfrm>
           <a:prstGeom prst="roundRect">
             <a:avLst>
@@ -15850,7 +16542,7 @@
           <a:p>
             <a:pPr algn="l"/>
             <a:r>
-              <a:rPr sz="1250" b="0">
+              <a:rPr sz="1600" b="0">
                 <a:solidFill>
                   <a:srgbClr val="F4F8FC"/>
                 </a:solidFill>
@@ -15869,8 +16561,8 @@
         </p:nvSpPr>
         <p:spPr>
           <a:xfrm>
-            <a:off x="6236208" y="5696712"/>
-            <a:ext cx="5321808" cy="475488"/>
+            <a:off x="640080" y="5696712"/>
+            <a:ext cx="3493008" cy="512064"/>
           </a:xfrm>
           <a:prstGeom prst="roundRect">
             <a:avLst>
@@ -15906,7 +16598,7 @@
           <a:p>
             <a:pPr algn="l"/>
             <a:r>
-              <a:rPr sz="1250" b="0">
+              <a:rPr sz="1600" b="0">
                 <a:solidFill>
                   <a:srgbClr val="F4F8FC"/>
                 </a:solidFill>

</xml_diff>

<commit_message>
fix: improve technical slide readability
</commit_message>
<xml_diff>
--- a/docs/presentations/AI-ChotBot-technical-achievements.pptx
+++ b/docs/presentations/AI-ChotBot-technical-achievements.pptx
@@ -5317,8 +5317,8 @@
         </p:nvSpPr>
         <p:spPr>
           <a:xfrm>
-            <a:off x="640080" y="5074920"/>
-            <a:ext cx="3493008" cy="512064"/>
+            <a:off x="640080" y="4251960"/>
+            <a:ext cx="5321808" cy="603504"/>
           </a:xfrm>
           <a:prstGeom prst="roundRect">
             <a:avLst>
@@ -5373,8 +5373,8 @@
         </p:nvSpPr>
         <p:spPr>
           <a:xfrm>
-            <a:off x="4315968" y="5074920"/>
-            <a:ext cx="3493008" cy="512064"/>
+            <a:off x="6236208" y="4251960"/>
+            <a:ext cx="5321808" cy="603504"/>
           </a:xfrm>
           <a:prstGeom prst="roundRect">
             <a:avLst>
@@ -5429,8 +5429,8 @@
         </p:nvSpPr>
         <p:spPr>
           <a:xfrm>
-            <a:off x="7991855" y="5074920"/>
-            <a:ext cx="3493008" cy="512064"/>
+            <a:off x="640080" y="4928616"/>
+            <a:ext cx="5321808" cy="603504"/>
           </a:xfrm>
           <a:prstGeom prst="roundRect">
             <a:avLst>
@@ -5485,8 +5485,8 @@
         </p:nvSpPr>
         <p:spPr>
           <a:xfrm>
-            <a:off x="640080" y="5696712"/>
-            <a:ext cx="3493008" cy="512064"/>
+            <a:off x="6236208" y="4928616"/>
+            <a:ext cx="5321808" cy="603504"/>
           </a:xfrm>
           <a:prstGeom prst="roundRect">
             <a:avLst>
@@ -5974,8 +5974,8 @@
         </p:nvSpPr>
         <p:spPr>
           <a:xfrm>
-            <a:off x="640080" y="5074920"/>
-            <a:ext cx="3493008" cy="512064"/>
+            <a:off x="640080" y="4251960"/>
+            <a:ext cx="5321808" cy="603504"/>
           </a:xfrm>
           <a:prstGeom prst="roundRect">
             <a:avLst>
@@ -6030,8 +6030,8 @@
         </p:nvSpPr>
         <p:spPr>
           <a:xfrm>
-            <a:off x="4315968" y="5074920"/>
-            <a:ext cx="3493008" cy="512064"/>
+            <a:off x="6236208" y="4251960"/>
+            <a:ext cx="5321808" cy="603504"/>
           </a:xfrm>
           <a:prstGeom prst="roundRect">
             <a:avLst>
@@ -6086,8 +6086,8 @@
         </p:nvSpPr>
         <p:spPr>
           <a:xfrm>
-            <a:off x="7991855" y="5074920"/>
-            <a:ext cx="3493008" cy="512064"/>
+            <a:off x="640080" y="4928616"/>
+            <a:ext cx="5321808" cy="603504"/>
           </a:xfrm>
           <a:prstGeom prst="roundRect">
             <a:avLst>
@@ -6142,8 +6142,8 @@
         </p:nvSpPr>
         <p:spPr>
           <a:xfrm>
-            <a:off x="640080" y="5696712"/>
-            <a:ext cx="3493008" cy="512064"/>
+            <a:off x="6236208" y="4928616"/>
+            <a:ext cx="5321808" cy="603504"/>
           </a:xfrm>
           <a:prstGeom prst="roundRect">
             <a:avLst>
@@ -6198,8 +6198,8 @@
         </p:nvSpPr>
         <p:spPr>
           <a:xfrm>
-            <a:off x="4315968" y="5696712"/>
-            <a:ext cx="3493008" cy="512064"/>
+            <a:off x="640080" y="5605272"/>
+            <a:ext cx="5321808" cy="603504"/>
           </a:xfrm>
           <a:prstGeom prst="roundRect">
             <a:avLst>
@@ -7055,8 +7055,8 @@
         </p:nvSpPr>
         <p:spPr>
           <a:xfrm>
-            <a:off x="640080" y="5074920"/>
-            <a:ext cx="3493008" cy="512064"/>
+            <a:off x="640080" y="4251960"/>
+            <a:ext cx="5321808" cy="603504"/>
           </a:xfrm>
           <a:prstGeom prst="roundRect">
             <a:avLst>
@@ -7111,8 +7111,8 @@
         </p:nvSpPr>
         <p:spPr>
           <a:xfrm>
-            <a:off x="4315968" y="5074920"/>
-            <a:ext cx="3493008" cy="512064"/>
+            <a:off x="6236208" y="4251960"/>
+            <a:ext cx="5321808" cy="603504"/>
           </a:xfrm>
           <a:prstGeom prst="roundRect">
             <a:avLst>
@@ -7167,8 +7167,8 @@
         </p:nvSpPr>
         <p:spPr>
           <a:xfrm>
-            <a:off x="7991855" y="5074920"/>
-            <a:ext cx="3493008" cy="512064"/>
+            <a:off x="640080" y="4928616"/>
+            <a:ext cx="5321808" cy="603504"/>
           </a:xfrm>
           <a:prstGeom prst="roundRect">
             <a:avLst>
@@ -7223,8 +7223,8 @@
         </p:nvSpPr>
         <p:spPr>
           <a:xfrm>
-            <a:off x="640080" y="5696712"/>
-            <a:ext cx="3493008" cy="512064"/>
+            <a:off x="6236208" y="4928616"/>
+            <a:ext cx="5321808" cy="603504"/>
           </a:xfrm>
           <a:prstGeom prst="roundRect">
             <a:avLst>
@@ -7279,8 +7279,8 @@
         </p:nvSpPr>
         <p:spPr>
           <a:xfrm>
-            <a:off x="4315968" y="5696712"/>
-            <a:ext cx="3493008" cy="512064"/>
+            <a:off x="640080" y="5605272"/>
+            <a:ext cx="5321808" cy="603504"/>
           </a:xfrm>
           <a:prstGeom prst="roundRect">
             <a:avLst>
@@ -7741,7 +7741,7 @@
                 </a:solidFill>
                 <a:latin typeface="Microsoft JhengHei"/>
               </a:rPr>
-              <a:t>**開發中**：功能位於獨立分支，尚未合併至主線或正式部署</a:t>
+              <a:t>開發中：功能位於獨立分支，尚未合併至主線或正式部署</a:t>
             </a:r>
           </a:p>
         </p:txBody>
@@ -7824,8 +7824,8 @@
         </p:nvSpPr>
         <p:spPr>
           <a:xfrm>
-            <a:off x="640080" y="5074920"/>
-            <a:ext cx="3493008" cy="512064"/>
+            <a:off x="640080" y="4251960"/>
+            <a:ext cx="5321808" cy="603504"/>
           </a:xfrm>
           <a:prstGeom prst="roundRect">
             <a:avLst>
@@ -7867,7 +7867,7 @@
                 </a:solidFill>
                 <a:latin typeface="Microsoft JhengHei"/>
               </a:rPr>
-              <a:t>**開發中**：功能位於獨立分支，尚未合併至主線或正式部署</a:t>
+              <a:t>開發中：功能位於獨立分支，尚未合併至主線或正式部署</a:t>
             </a:r>
           </a:p>
         </p:txBody>
@@ -7880,8 +7880,8 @@
         </p:nvSpPr>
         <p:spPr>
           <a:xfrm>
-            <a:off x="4315968" y="5074920"/>
-            <a:ext cx="3493008" cy="512064"/>
+            <a:off x="6236208" y="4251960"/>
+            <a:ext cx="5321808" cy="603504"/>
           </a:xfrm>
           <a:prstGeom prst="roundRect">
             <a:avLst>
@@ -7936,8 +7936,8 @@
         </p:nvSpPr>
         <p:spPr>
           <a:xfrm>
-            <a:off x="7991855" y="5074920"/>
-            <a:ext cx="3493008" cy="512064"/>
+            <a:off x="640080" y="4928616"/>
+            <a:ext cx="5321808" cy="603504"/>
           </a:xfrm>
           <a:prstGeom prst="roundRect">
             <a:avLst>
@@ -7992,8 +7992,8 @@
         </p:nvSpPr>
         <p:spPr>
           <a:xfrm>
-            <a:off x="640080" y="5696712"/>
-            <a:ext cx="3493008" cy="512064"/>
+            <a:off x="6236208" y="4928616"/>
+            <a:ext cx="5321808" cy="603504"/>
           </a:xfrm>
           <a:prstGeom prst="roundRect">
             <a:avLst>
@@ -8048,8 +8048,8 @@
         </p:nvSpPr>
         <p:spPr>
           <a:xfrm>
-            <a:off x="4315968" y="5696712"/>
-            <a:ext cx="3493008" cy="512064"/>
+            <a:off x="640080" y="5605272"/>
+            <a:ext cx="5321808" cy="603504"/>
           </a:xfrm>
           <a:prstGeom prst="roundRect">
             <a:avLst>
@@ -8761,8 +8761,8 @@
         </p:nvSpPr>
         <p:spPr>
           <a:xfrm>
-            <a:off x="640080" y="5074920"/>
-            <a:ext cx="3493008" cy="512064"/>
+            <a:off x="640080" y="4251960"/>
+            <a:ext cx="5321808" cy="603504"/>
           </a:xfrm>
           <a:prstGeom prst="roundRect">
             <a:avLst>
@@ -8817,8 +8817,8 @@
         </p:nvSpPr>
         <p:spPr>
           <a:xfrm>
-            <a:off x="4315968" y="5074920"/>
-            <a:ext cx="3493008" cy="512064"/>
+            <a:off x="6236208" y="4251960"/>
+            <a:ext cx="5321808" cy="603504"/>
           </a:xfrm>
           <a:prstGeom prst="roundRect">
             <a:avLst>
@@ -8873,8 +8873,8 @@
         </p:nvSpPr>
         <p:spPr>
           <a:xfrm>
-            <a:off x="7991855" y="5074920"/>
-            <a:ext cx="3493008" cy="512064"/>
+            <a:off x="640080" y="4928616"/>
+            <a:ext cx="5321808" cy="603504"/>
           </a:xfrm>
           <a:prstGeom prst="roundRect">
             <a:avLst>
@@ -8929,8 +8929,8 @@
         </p:nvSpPr>
         <p:spPr>
           <a:xfrm>
-            <a:off x="640080" y="5696712"/>
-            <a:ext cx="3493008" cy="512064"/>
+            <a:off x="6236208" y="4928616"/>
+            <a:ext cx="5321808" cy="603504"/>
           </a:xfrm>
           <a:prstGeom prst="roundRect">
             <a:avLst>
@@ -9795,8 +9795,8 @@
         </p:nvSpPr>
         <p:spPr>
           <a:xfrm>
-            <a:off x="640080" y="5074920"/>
-            <a:ext cx="3493008" cy="512064"/>
+            <a:off x="640080" y="4251960"/>
+            <a:ext cx="5321808" cy="603504"/>
           </a:xfrm>
           <a:prstGeom prst="roundRect">
             <a:avLst>
@@ -9851,8 +9851,8 @@
         </p:nvSpPr>
         <p:spPr>
           <a:xfrm>
-            <a:off x="4315968" y="5074920"/>
-            <a:ext cx="3493008" cy="512064"/>
+            <a:off x="6236208" y="4251960"/>
+            <a:ext cx="5321808" cy="603504"/>
           </a:xfrm>
           <a:prstGeom prst="roundRect">
             <a:avLst>
@@ -9907,8 +9907,8 @@
         </p:nvSpPr>
         <p:spPr>
           <a:xfrm>
-            <a:off x="7991855" y="5074920"/>
-            <a:ext cx="3493008" cy="512064"/>
+            <a:off x="640080" y="4928616"/>
+            <a:ext cx="5321808" cy="603504"/>
           </a:xfrm>
           <a:prstGeom prst="roundRect">
             <a:avLst>
@@ -9963,8 +9963,8 @@
         </p:nvSpPr>
         <p:spPr>
           <a:xfrm>
-            <a:off x="640080" y="5696712"/>
-            <a:ext cx="3493008" cy="512064"/>
+            <a:off x="6236208" y="4928616"/>
+            <a:ext cx="5321808" cy="603504"/>
           </a:xfrm>
           <a:prstGeom prst="roundRect">
             <a:avLst>
@@ -10019,8 +10019,8 @@
         </p:nvSpPr>
         <p:spPr>
           <a:xfrm>
-            <a:off x="4315968" y="5696712"/>
-            <a:ext cx="3493008" cy="512064"/>
+            <a:off x="640080" y="5605272"/>
+            <a:ext cx="5321808" cy="603504"/>
           </a:xfrm>
           <a:prstGeom prst="roundRect">
             <a:avLst>
@@ -11253,8 +11253,8 @@
         </p:nvSpPr>
         <p:spPr>
           <a:xfrm>
-            <a:off x="640080" y="5074920"/>
-            <a:ext cx="3493008" cy="512064"/>
+            <a:off x="640080" y="4251960"/>
+            <a:ext cx="5321808" cy="603504"/>
           </a:xfrm>
           <a:prstGeom prst="roundRect">
             <a:avLst>
@@ -11309,8 +11309,8 @@
         </p:nvSpPr>
         <p:spPr>
           <a:xfrm>
-            <a:off x="4315968" y="5074920"/>
-            <a:ext cx="3493008" cy="512064"/>
+            <a:off x="6236208" y="4251960"/>
+            <a:ext cx="5321808" cy="603504"/>
           </a:xfrm>
           <a:prstGeom prst="roundRect">
             <a:avLst>
@@ -11365,8 +11365,8 @@
         </p:nvSpPr>
         <p:spPr>
           <a:xfrm>
-            <a:off x="7991855" y="5074920"/>
-            <a:ext cx="3493008" cy="512064"/>
+            <a:off x="640080" y="4928616"/>
+            <a:ext cx="5321808" cy="603504"/>
           </a:xfrm>
           <a:prstGeom prst="roundRect">
             <a:avLst>
@@ -11421,8 +11421,8 @@
         </p:nvSpPr>
         <p:spPr>
           <a:xfrm>
-            <a:off x="640080" y="5696712"/>
-            <a:ext cx="3493008" cy="512064"/>
+            <a:off x="6236208" y="4928616"/>
+            <a:ext cx="5321808" cy="603504"/>
           </a:xfrm>
           <a:prstGeom prst="roundRect">
             <a:avLst>
@@ -12357,8 +12357,8 @@
         </p:nvSpPr>
         <p:spPr>
           <a:xfrm>
-            <a:off x="640080" y="5074920"/>
-            <a:ext cx="3493008" cy="512064"/>
+            <a:off x="640080" y="4251960"/>
+            <a:ext cx="5321808" cy="603504"/>
           </a:xfrm>
           <a:prstGeom prst="roundRect">
             <a:avLst>
@@ -12413,8 +12413,8 @@
         </p:nvSpPr>
         <p:spPr>
           <a:xfrm>
-            <a:off x="4315968" y="5074920"/>
-            <a:ext cx="3493008" cy="512064"/>
+            <a:off x="6236208" y="4251960"/>
+            <a:ext cx="5321808" cy="603504"/>
           </a:xfrm>
           <a:prstGeom prst="roundRect">
             <a:avLst>
@@ -12469,8 +12469,8 @@
         </p:nvSpPr>
         <p:spPr>
           <a:xfrm>
-            <a:off x="7991855" y="5074920"/>
-            <a:ext cx="3493008" cy="512064"/>
+            <a:off x="640080" y="4928616"/>
+            <a:ext cx="5321808" cy="603504"/>
           </a:xfrm>
           <a:prstGeom prst="roundRect">
             <a:avLst>
@@ -12525,8 +12525,8 @@
         </p:nvSpPr>
         <p:spPr>
           <a:xfrm>
-            <a:off x="640080" y="5696712"/>
-            <a:ext cx="3493008" cy="512064"/>
+            <a:off x="6236208" y="4928616"/>
+            <a:ext cx="5321808" cy="603504"/>
           </a:xfrm>
           <a:prstGeom prst="roundRect">
             <a:avLst>
@@ -13362,8 +13362,8 @@
         </p:nvSpPr>
         <p:spPr>
           <a:xfrm>
-            <a:off x="640080" y="5074920"/>
-            <a:ext cx="3493008" cy="512064"/>
+            <a:off x="640080" y="4251960"/>
+            <a:ext cx="5321808" cy="603504"/>
           </a:xfrm>
           <a:prstGeom prst="roundRect">
             <a:avLst>
@@ -13418,8 +13418,8 @@
         </p:nvSpPr>
         <p:spPr>
           <a:xfrm>
-            <a:off x="4315968" y="5074920"/>
-            <a:ext cx="3493008" cy="512064"/>
+            <a:off x="6236208" y="4251960"/>
+            <a:ext cx="5321808" cy="603504"/>
           </a:xfrm>
           <a:prstGeom prst="roundRect">
             <a:avLst>
@@ -13474,8 +13474,8 @@
         </p:nvSpPr>
         <p:spPr>
           <a:xfrm>
-            <a:off x="7991855" y="5074920"/>
-            <a:ext cx="3493008" cy="512064"/>
+            <a:off x="640080" y="4928616"/>
+            <a:ext cx="5321808" cy="603504"/>
           </a:xfrm>
           <a:prstGeom prst="roundRect">
             <a:avLst>
@@ -13530,8 +13530,8 @@
         </p:nvSpPr>
         <p:spPr>
           <a:xfrm>
-            <a:off x="640080" y="5696712"/>
-            <a:ext cx="3493008" cy="512064"/>
+            <a:off x="6236208" y="4928616"/>
+            <a:ext cx="5321808" cy="603504"/>
           </a:xfrm>
           <a:prstGeom prst="roundRect">
             <a:avLst>
@@ -14183,8 +14183,8 @@
         </p:nvSpPr>
         <p:spPr>
           <a:xfrm>
-            <a:off x="640080" y="5074920"/>
-            <a:ext cx="3493008" cy="512064"/>
+            <a:off x="640080" y="4251960"/>
+            <a:ext cx="5321808" cy="603504"/>
           </a:xfrm>
           <a:prstGeom prst="roundRect">
             <a:avLst>
@@ -14239,8 +14239,8 @@
         </p:nvSpPr>
         <p:spPr>
           <a:xfrm>
-            <a:off x="4315968" y="5074920"/>
-            <a:ext cx="3493008" cy="512064"/>
+            <a:off x="6236208" y="4251960"/>
+            <a:ext cx="5321808" cy="603504"/>
           </a:xfrm>
           <a:prstGeom prst="roundRect">
             <a:avLst>
@@ -14295,8 +14295,8 @@
         </p:nvSpPr>
         <p:spPr>
           <a:xfrm>
-            <a:off x="7991855" y="5074920"/>
-            <a:ext cx="3493008" cy="512064"/>
+            <a:off x="640080" y="4928616"/>
+            <a:ext cx="5321808" cy="603504"/>
           </a:xfrm>
           <a:prstGeom prst="roundRect">
             <a:avLst>
@@ -14351,8 +14351,8 @@
         </p:nvSpPr>
         <p:spPr>
           <a:xfrm>
-            <a:off x="640080" y="5696712"/>
-            <a:ext cx="3493008" cy="512064"/>
+            <a:off x="6236208" y="4928616"/>
+            <a:ext cx="5321808" cy="603504"/>
           </a:xfrm>
           <a:prstGeom prst="roundRect">
             <a:avLst>
@@ -14915,8 +14915,8 @@
         </p:nvSpPr>
         <p:spPr>
           <a:xfrm>
-            <a:off x="640080" y="5074920"/>
-            <a:ext cx="3493008" cy="512064"/>
+            <a:off x="640080" y="4251960"/>
+            <a:ext cx="5321808" cy="603504"/>
           </a:xfrm>
           <a:prstGeom prst="roundRect">
             <a:avLst>
@@ -14971,8 +14971,8 @@
         </p:nvSpPr>
         <p:spPr>
           <a:xfrm>
-            <a:off x="4315968" y="5074920"/>
-            <a:ext cx="3493008" cy="512064"/>
+            <a:off x="6236208" y="4251960"/>
+            <a:ext cx="5321808" cy="603504"/>
           </a:xfrm>
           <a:prstGeom prst="roundRect">
             <a:avLst>
@@ -15027,8 +15027,8 @@
         </p:nvSpPr>
         <p:spPr>
           <a:xfrm>
-            <a:off x="7991855" y="5074920"/>
-            <a:ext cx="3493008" cy="512064"/>
+            <a:off x="640080" y="4928616"/>
+            <a:ext cx="5321808" cy="603504"/>
           </a:xfrm>
           <a:prstGeom prst="roundRect">
             <a:avLst>
@@ -15083,8 +15083,8 @@
         </p:nvSpPr>
         <p:spPr>
           <a:xfrm>
-            <a:off x="640080" y="5696712"/>
-            <a:ext cx="3493008" cy="512064"/>
+            <a:off x="6236208" y="4928616"/>
+            <a:ext cx="5321808" cy="603504"/>
           </a:xfrm>
           <a:prstGeom prst="roundRect">
             <a:avLst>
@@ -15572,8 +15572,8 @@
         </p:nvSpPr>
         <p:spPr>
           <a:xfrm>
-            <a:off x="640080" y="5074920"/>
-            <a:ext cx="3493008" cy="512064"/>
+            <a:off x="640080" y="4251960"/>
+            <a:ext cx="5321808" cy="603504"/>
           </a:xfrm>
           <a:prstGeom prst="roundRect">
             <a:avLst>
@@ -15628,8 +15628,8 @@
         </p:nvSpPr>
         <p:spPr>
           <a:xfrm>
-            <a:off x="4315968" y="5074920"/>
-            <a:ext cx="3493008" cy="512064"/>
+            <a:off x="6236208" y="4251960"/>
+            <a:ext cx="5321808" cy="603504"/>
           </a:xfrm>
           <a:prstGeom prst="roundRect">
             <a:avLst>
@@ -15684,8 +15684,8 @@
         </p:nvSpPr>
         <p:spPr>
           <a:xfrm>
-            <a:off x="7991855" y="5074920"/>
-            <a:ext cx="3493008" cy="512064"/>
+            <a:off x="640080" y="4928616"/>
+            <a:ext cx="5321808" cy="603504"/>
           </a:xfrm>
           <a:prstGeom prst="roundRect">
             <a:avLst>
@@ -15740,8 +15740,8 @@
         </p:nvSpPr>
         <p:spPr>
           <a:xfrm>
-            <a:off x="640080" y="5696712"/>
-            <a:ext cx="3493008" cy="512064"/>
+            <a:off x="6236208" y="4928616"/>
+            <a:ext cx="5321808" cy="603504"/>
           </a:xfrm>
           <a:prstGeom prst="roundRect">
             <a:avLst>
@@ -16393,8 +16393,8 @@
         </p:nvSpPr>
         <p:spPr>
           <a:xfrm>
-            <a:off x="640080" y="5074920"/>
-            <a:ext cx="3493008" cy="512064"/>
+            <a:off x="640080" y="4251960"/>
+            <a:ext cx="5321808" cy="603504"/>
           </a:xfrm>
           <a:prstGeom prst="roundRect">
             <a:avLst>
@@ -16449,8 +16449,8 @@
         </p:nvSpPr>
         <p:spPr>
           <a:xfrm>
-            <a:off x="4315968" y="5074920"/>
-            <a:ext cx="3493008" cy="512064"/>
+            <a:off x="6236208" y="4251960"/>
+            <a:ext cx="5321808" cy="603504"/>
           </a:xfrm>
           <a:prstGeom prst="roundRect">
             <a:avLst>
@@ -16505,8 +16505,8 @@
         </p:nvSpPr>
         <p:spPr>
           <a:xfrm>
-            <a:off x="7991855" y="5074920"/>
-            <a:ext cx="3493008" cy="512064"/>
+            <a:off x="640080" y="4928616"/>
+            <a:ext cx="5321808" cy="603504"/>
           </a:xfrm>
           <a:prstGeom prst="roundRect">
             <a:avLst>
@@ -16561,8 +16561,8 @@
         </p:nvSpPr>
         <p:spPr>
           <a:xfrm>
-            <a:off x="640080" y="5696712"/>
-            <a:ext cx="3493008" cy="512064"/>
+            <a:off x="6236208" y="4928616"/>
+            <a:ext cx="5321808" cy="603504"/>
           </a:xfrm>
           <a:prstGeom prst="roundRect">
             <a:avLst>

</xml_diff>

<commit_message>
fix: align technical architecture diagrams
</commit_message>
<xml_diff>
--- a/docs/presentations/AI-ChotBot-technical-achievements.pptx
+++ b/docs/presentations/AI-ChotBot-technical-achievements.pptx
@@ -8104,8 +8104,8 @@
         </p:nvSpPr>
         <p:spPr>
           <a:xfrm>
-            <a:off x="777240" y="1828800"/>
-            <a:ext cx="2834640" cy="493776"/>
+            <a:off x="411480" y="1828800"/>
+            <a:ext cx="1691640" cy="530352"/>
           </a:xfrm>
           <a:prstGeom prst="roundRect">
             <a:avLst>
@@ -8141,7 +8141,7 @@
           <a:p>
             <a:pPr algn="ctr"/>
             <a:r>
-              <a:rPr sz="1300" b="1">
+              <a:rPr sz="1200" b="1">
                 <a:solidFill>
                   <a:srgbClr val="F4F8FC"/>
                 </a:solidFill>
@@ -8160,8 +8160,8 @@
         </p:nvSpPr>
         <p:spPr>
           <a:xfrm>
-            <a:off x="4480559" y="1828800"/>
-            <a:ext cx="2834640" cy="493776"/>
+            <a:off x="2331720" y="1828800"/>
+            <a:ext cx="1691640" cy="530352"/>
           </a:xfrm>
           <a:prstGeom prst="roundRect">
             <a:avLst>
@@ -8197,7 +8197,7 @@
           <a:p>
             <a:pPr algn="ctr"/>
             <a:r>
-              <a:rPr sz="1300" b="1">
+              <a:rPr sz="1200" b="1">
                 <a:solidFill>
                   <a:srgbClr val="F4F8FC"/>
                 </a:solidFill>
@@ -8208,16 +8208,52 @@
           </a:p>
         </p:txBody>
       </p:sp>
-      <p:sp>
-        <p:nvSpPr>
-          <p:cNvPr id="15" name="knowledge-node-workers-ai"/>
+      <p:cxnSp>
+        <p:nvCxnSpPr>
+          <p:cNvPr id="15" name="knowledge-connector-1"/>
+          <p:cNvCxnSpPr/>
+          <p:nvPr/>
+        </p:nvCxnSpPr>
+        <p:spPr>
+          <a:xfrm>
+            <a:off x="2103120" y="2093976"/>
+            <a:ext cx="228600" cy="0"/>
+          </a:xfrm>
+          <a:prstGeom prst="line">
+            <a:avLst/>
+          </a:prstGeom>
+          <a:ln w="22860">
+            <a:solidFill>
+              <a:srgbClr val="4BA3FF"/>
+            </a:solidFill>
+            <a:tailEnd type="triangle"/>
+          </a:ln>
+        </p:spPr>
+        <p:style>
+          <a:lnRef idx="2">
+            <a:schemeClr val="accent1"/>
+          </a:lnRef>
+          <a:fillRef idx="0">
+            <a:schemeClr val="accent1"/>
+          </a:fillRef>
+          <a:effectRef idx="1">
+            <a:schemeClr val="accent1"/>
+          </a:effectRef>
+          <a:fontRef idx="minor">
+            <a:schemeClr val="tx1"/>
+          </a:fontRef>
+        </p:style>
+      </p:cxnSp>
+      <p:sp>
+        <p:nvSpPr>
+          <p:cNvPr id="16" name="knowledge-node-workers-ai"/>
           <p:cNvSpPr/>
           <p:nvPr/>
         </p:nvSpPr>
         <p:spPr>
           <a:xfrm>
-            <a:off x="8183879" y="1828800"/>
-            <a:ext cx="2834640" cy="493776"/>
+            <a:off x="4251960" y="1828800"/>
+            <a:ext cx="1691640" cy="530352"/>
           </a:xfrm>
           <a:prstGeom prst="roundRect">
             <a:avLst>
@@ -8253,7 +8289,7 @@
           <a:p>
             <a:pPr algn="ctr"/>
             <a:r>
-              <a:rPr sz="1300" b="1">
+              <a:rPr sz="1200" b="1">
                 <a:solidFill>
                   <a:srgbClr val="F4F8FC"/>
                 </a:solidFill>
@@ -8264,16 +8300,52 @@
           </a:p>
         </p:txBody>
       </p:sp>
-      <p:sp>
-        <p:nvSpPr>
-          <p:cNvPr id="16" name="knowledge-node-vectorize"/>
+      <p:cxnSp>
+        <p:nvCxnSpPr>
+          <p:cNvPr id="17" name="knowledge-connector-2"/>
+          <p:cNvCxnSpPr/>
+          <p:nvPr/>
+        </p:nvCxnSpPr>
+        <p:spPr>
+          <a:xfrm>
+            <a:off x="4023360" y="2093976"/>
+            <a:ext cx="228600" cy="0"/>
+          </a:xfrm>
+          <a:prstGeom prst="line">
+            <a:avLst/>
+          </a:prstGeom>
+          <a:ln w="22860">
+            <a:solidFill>
+              <a:srgbClr val="4BA3FF"/>
+            </a:solidFill>
+            <a:tailEnd type="triangle"/>
+          </a:ln>
+        </p:spPr>
+        <p:style>
+          <a:lnRef idx="2">
+            <a:schemeClr val="accent1"/>
+          </a:lnRef>
+          <a:fillRef idx="0">
+            <a:schemeClr val="accent1"/>
+          </a:fillRef>
+          <a:effectRef idx="1">
+            <a:schemeClr val="accent1"/>
+          </a:effectRef>
+          <a:fontRef idx="minor">
+            <a:schemeClr val="tx1"/>
+          </a:fontRef>
+        </p:style>
+      </p:cxnSp>
+      <p:sp>
+        <p:nvSpPr>
+          <p:cNvPr id="18" name="knowledge-node-vectorize"/>
           <p:cNvSpPr/>
           <p:nvPr/>
         </p:nvSpPr>
         <p:spPr>
           <a:xfrm>
-            <a:off x="777240" y="2633472"/>
-            <a:ext cx="2834640" cy="493776"/>
+            <a:off x="6172200" y="1828800"/>
+            <a:ext cx="1691640" cy="530352"/>
           </a:xfrm>
           <a:prstGeom prst="roundRect">
             <a:avLst>
@@ -8309,7 +8381,7 @@
           <a:p>
             <a:pPr algn="ctr"/>
             <a:r>
-              <a:rPr sz="1300" b="1">
+              <a:rPr sz="1200" b="1">
                 <a:solidFill>
                   <a:srgbClr val="F4F8FC"/>
                 </a:solidFill>
@@ -8320,16 +8392,52 @@
           </a:p>
         </p:txBody>
       </p:sp>
-      <p:sp>
-        <p:nvSpPr>
-          <p:cNvPr id="17" name="knowledge-node-retrieval"/>
+      <p:cxnSp>
+        <p:nvCxnSpPr>
+          <p:cNvPr id="19" name="knowledge-connector-3"/>
+          <p:cNvCxnSpPr/>
+          <p:nvPr/>
+        </p:nvCxnSpPr>
+        <p:spPr>
+          <a:xfrm>
+            <a:off x="5943600" y="2093976"/>
+            <a:ext cx="228600" cy="0"/>
+          </a:xfrm>
+          <a:prstGeom prst="line">
+            <a:avLst/>
+          </a:prstGeom>
+          <a:ln w="22860">
+            <a:solidFill>
+              <a:srgbClr val="4BA3FF"/>
+            </a:solidFill>
+            <a:tailEnd type="triangle"/>
+          </a:ln>
+        </p:spPr>
+        <p:style>
+          <a:lnRef idx="2">
+            <a:schemeClr val="accent1"/>
+          </a:lnRef>
+          <a:fillRef idx="0">
+            <a:schemeClr val="accent1"/>
+          </a:fillRef>
+          <a:effectRef idx="1">
+            <a:schemeClr val="accent1"/>
+          </a:effectRef>
+          <a:fontRef idx="minor">
+            <a:schemeClr val="tx1"/>
+          </a:fontRef>
+        </p:style>
+      </p:cxnSp>
+      <p:sp>
+        <p:nvSpPr>
+          <p:cNvPr id="20" name="knowledge-node-retrieval"/>
           <p:cNvSpPr/>
           <p:nvPr/>
         </p:nvSpPr>
         <p:spPr>
           <a:xfrm>
-            <a:off x="4480559" y="2633472"/>
-            <a:ext cx="2834640" cy="493776"/>
+            <a:off x="8092440" y="1828800"/>
+            <a:ext cx="1691640" cy="530352"/>
           </a:xfrm>
           <a:prstGeom prst="roundRect">
             <a:avLst>
@@ -8365,7 +8473,7 @@
           <a:p>
             <a:pPr algn="ctr"/>
             <a:r>
-              <a:rPr sz="1300" b="1">
+              <a:rPr sz="1200" b="1">
                 <a:solidFill>
                   <a:srgbClr val="F4F8FC"/>
                 </a:solidFill>
@@ -8376,16 +8484,52 @@
           </a:p>
         </p:txBody>
       </p:sp>
-      <p:sp>
-        <p:nvSpPr>
-          <p:cNvPr id="18" name="knowledge-node-grounded-answer"/>
+      <p:cxnSp>
+        <p:nvCxnSpPr>
+          <p:cNvPr id="21" name="knowledge-connector-4"/>
+          <p:cNvCxnSpPr/>
+          <p:nvPr/>
+        </p:nvCxnSpPr>
+        <p:spPr>
+          <a:xfrm>
+            <a:off x="7863840" y="2093976"/>
+            <a:ext cx="228600" cy="0"/>
+          </a:xfrm>
+          <a:prstGeom prst="line">
+            <a:avLst/>
+          </a:prstGeom>
+          <a:ln w="22860">
+            <a:solidFill>
+              <a:srgbClr val="4BA3FF"/>
+            </a:solidFill>
+            <a:tailEnd type="triangle"/>
+          </a:ln>
+        </p:spPr>
+        <p:style>
+          <a:lnRef idx="2">
+            <a:schemeClr val="accent1"/>
+          </a:lnRef>
+          <a:fillRef idx="0">
+            <a:schemeClr val="accent1"/>
+          </a:fillRef>
+          <a:effectRef idx="1">
+            <a:schemeClr val="accent1"/>
+          </a:effectRef>
+          <a:fontRef idx="minor">
+            <a:schemeClr val="tx1"/>
+          </a:fontRef>
+        </p:style>
+      </p:cxnSp>
+      <p:sp>
+        <p:nvSpPr>
+          <p:cNvPr id="22" name="knowledge-node-grounded-answer"/>
           <p:cNvSpPr/>
           <p:nvPr/>
         </p:nvSpPr>
         <p:spPr>
           <a:xfrm>
-            <a:off x="8183879" y="2633472"/>
-            <a:ext cx="2834640" cy="493776"/>
+            <a:off x="10012680" y="1828800"/>
+            <a:ext cx="1691640" cy="530352"/>
           </a:xfrm>
           <a:prstGeom prst="roundRect">
             <a:avLst>
@@ -8421,7 +8565,7 @@
           <a:p>
             <a:pPr algn="ctr"/>
             <a:r>
-              <a:rPr sz="1300" b="1">
+              <a:rPr sz="1200" b="1">
                 <a:solidFill>
                   <a:srgbClr val="F4F8FC"/>
                 </a:solidFill>
@@ -8432,15 +8576,51 @@
           </a:p>
         </p:txBody>
       </p:sp>
-      <p:sp>
-        <p:nvSpPr>
-          <p:cNvPr id="19" name="development-status-13"/>
+      <p:cxnSp>
+        <p:nvCxnSpPr>
+          <p:cNvPr id="23" name="knowledge-connector-5"/>
+          <p:cNvCxnSpPr/>
+          <p:nvPr/>
+        </p:nvCxnSpPr>
+        <p:spPr>
+          <a:xfrm>
+            <a:off x="9784080" y="2093976"/>
+            <a:ext cx="228600" cy="0"/>
+          </a:xfrm>
+          <a:prstGeom prst="line">
+            <a:avLst/>
+          </a:prstGeom>
+          <a:ln w="22860">
+            <a:solidFill>
+              <a:srgbClr val="4BA3FF"/>
+            </a:solidFill>
+            <a:tailEnd type="triangle"/>
+          </a:ln>
+        </p:spPr>
+        <p:style>
+          <a:lnRef idx="2">
+            <a:schemeClr val="accent1"/>
+          </a:lnRef>
+          <a:fillRef idx="0">
+            <a:schemeClr val="accent1"/>
+          </a:fillRef>
+          <a:effectRef idx="1">
+            <a:schemeClr val="accent1"/>
+          </a:effectRef>
+          <a:fontRef idx="minor">
+            <a:schemeClr val="tx1"/>
+          </a:fontRef>
+        </p:style>
+      </p:cxnSp>
+      <p:sp>
+        <p:nvSpPr>
+          <p:cNvPr id="24" name="development-status-13"/>
           <p:cNvSpPr/>
           <p:nvPr/>
         </p:nvSpPr>
         <p:spPr>
           <a:xfrm>
-            <a:off x="9601200" y="2834640"/>
+            <a:off x="5349240" y="2788920"/>
             <a:ext cx="1463040" cy="420624"/>
           </a:xfrm>
           <a:prstGeom prst="roundRect">
@@ -11514,14 +11694,13 @@
           <a:p>
             <a:pPr algn="ctr"/>
             <a:r>
-              <a:rPr sz="1300" b="1">
+              <a:rPr sz="1600" b="1">
                 <a:solidFill>
                   <a:srgbClr val="F4F8FC"/>
                 </a:solidFill>
                 <a:latin typeface="Microsoft JhengHei"/>
               </a:rPr>
-              <a:t>架構節點 1
-LINE</a:t>
+              <a:t>使用者</a:t>
             </a:r>
           </a:p>
         </p:txBody>
@@ -11571,14 +11750,13 @@
           <a:p>
             <a:pPr algn="ctr"/>
             <a:r>
-              <a:rPr sz="1300" b="1">
+              <a:rPr sz="1600" b="1">
                 <a:solidFill>
                   <a:srgbClr val="F4F8FC"/>
                 </a:solidFill>
                 <a:latin typeface="Microsoft JhengHei"/>
               </a:rPr>
-              <a:t>架構節點 2
-Webhook</a:t>
+              <a:t>LINE</a:t>
             </a:r>
           </a:p>
         </p:txBody>
@@ -11628,14 +11806,13 @@
           <a:p>
             <a:pPr algn="ctr"/>
             <a:r>
-              <a:rPr sz="1300" b="1">
+              <a:rPr sz="1600" b="1">
                 <a:solidFill>
                   <a:srgbClr val="F4F8FC"/>
                 </a:solidFill>
                 <a:latin typeface="Microsoft JhengHei"/>
               </a:rPr>
-              <a:t>架構節點 3
-Worker</a:t>
+              <a:t>Worker</a:t>
             </a:r>
           </a:p>
         </p:txBody>
@@ -11685,14 +11862,13 @@
           <a:p>
             <a:pPr algn="ctr"/>
             <a:r>
-              <a:rPr sz="1300" b="1">
+              <a:rPr sz="1600" b="1">
                 <a:solidFill>
                   <a:srgbClr val="F4F8FC"/>
                 </a:solidFill>
                 <a:latin typeface="Microsoft JhengHei"/>
               </a:rPr>
-              <a:t>架構節點 4
-Queue</a:t>
+              <a:t>Queue</a:t>
             </a:r>
           </a:p>
         </p:txBody>
@@ -11742,14 +11918,13 @@
           <a:p>
             <a:pPr algn="ctr"/>
             <a:r>
-              <a:rPr sz="1300" b="1">
+              <a:rPr sz="1600" b="1">
                 <a:solidFill>
                   <a:srgbClr val="F4F8FC"/>
                 </a:solidFill>
                 <a:latin typeface="Microsoft JhengHei"/>
               </a:rPr>
-              <a:t>架構節點 5
-Workers AI</a:t>
+              <a:t>AI</a:t>
             </a:r>
           </a:p>
         </p:txBody>
@@ -11799,14 +11974,13 @@
           <a:p>
             <a:pPr algn="ctr"/>
             <a:r>
-              <a:rPr sz="1300" b="1">
+              <a:rPr sz="1600" b="1">
                 <a:solidFill>
                   <a:srgbClr val="F4F8FC"/>
                 </a:solidFill>
                 <a:latin typeface="Microsoft JhengHei"/>
               </a:rPr>
-              <a:t>架構節點 6
-D1</a:t>
+              <a:t>D1</a:t>
             </a:r>
           </a:p>
         </p:txBody>
@@ -11856,14 +12030,13 @@
           <a:p>
             <a:pPr algn="ctr"/>
             <a:r>
-              <a:rPr sz="1300" b="1">
+              <a:rPr sz="1600" b="1">
                 <a:solidFill>
                   <a:srgbClr val="F4F8FC"/>
                 </a:solidFill>
                 <a:latin typeface="Microsoft JhengHei"/>
               </a:rPr>
-              <a:t>架構節點 7
-Open-Meteo</a:t>
+              <a:t>Open-Meteo</a:t>
             </a:r>
           </a:p>
         </p:txBody>

</xml_diff>